<commit_message>
Refresh pitch deck and add evidence recorder
</commit_message>
<xml_diff>
--- a/submission/CrossSignal-Hackathon-Pitch-Final.pptx
+++ b/submission/CrossSignal-Hackathon-Pitch-Final.pptx
@@ -789,7 +789,7 @@
           <a:lstStyle/>
           <a:p>
             <a:r>
-              <a:t>The defensibility comes from precommitment. A judge can inspect what the agent knew, how it was challenged, what was authorized, and what happened later.</a:t>
+              <a:t>This is the key proof slide. The same policy evaluates both cases. The authorized replay shows the complete path when every gate passes. The live GitHub Evidence Watch contract scored 85 for signal and 100 for stability, but execution quality was 93 because one of fifteen gates failed—so the correct autonomous decision was abstention. Outcome evidence remains pending until the sealed horizon matures.</a:t>
             </a:r>
           </a:p>
         </p:txBody>
@@ -859,7 +859,7 @@
           <a:lstStyle/>
           <a:p>
             <a:r>
-              <a:t>CrossSignal follows NIST-aligned risk-management reasoning without claiming certification. Public infrastructure has no broker mutation capability.</a:t>
+              <a:t>CrossSignal follows NIST-aligned risk-management reasoning without claiming certification. Public infrastructure and scheduled GitHub automation have no broker mutation capability. The cloud watcher always runs execute false and exports only a secret-free artifact.</a:t>
             </a:r>
           </a:p>
         </p:txBody>
@@ -999,7 +999,7 @@
           <a:lstStyle/>
           <a:p>
             <a:r>
-              <a:t>Close on the differentiator: CrossSignal makes AI trading decisions inspectable, challengeable, reproducible, and measurable. Invite judges to open the live application and repository.</a:t>
+              <a:t>Close on verified evidence: thirty-five tests pass in GitHub, the scheduled cloud watcher sealed a live contract, and the system abstained because one risk gate failed. CrossSignal makes AI trading decisions inspectable, challengeable, reproducible, and measurable. Invite judges to open the live application, repository, and Actions evidence artifact.</a:t>
             </a:r>
           </a:p>
         </p:txBody>
@@ -5422,7 +5422,7 @@
           <a:lstStyle/>
           <a:p>
             <a:pPr algn="l">
-              <a:defRPr sz="1000" b="0">
+              <a:defRPr sz="900" b="0">
                 <a:solidFill>
                   <a:srgbClr val="53657D"/>
                 </a:solidFill>
@@ -5611,7 +5611,7 @@
           <a:lstStyle/>
           <a:p>
             <a:pPr algn="l">
-              <a:defRPr sz="1000" b="0">
+              <a:defRPr sz="900" b="0">
                 <a:solidFill>
                   <a:srgbClr val="53657D"/>
                 </a:solidFill>
@@ -5800,7 +5800,7 @@
           <a:lstStyle/>
           <a:p>
             <a:pPr algn="l">
-              <a:defRPr sz="1000" b="0">
+              <a:defRPr sz="900" b="0">
                 <a:solidFill>
                   <a:srgbClr val="72D4E8"/>
                 </a:solidFill>
@@ -5989,7 +5989,7 @@
           <a:lstStyle/>
           <a:p>
             <a:pPr algn="l">
-              <a:defRPr sz="1000" b="0">
+              <a:defRPr sz="900" b="0">
                 <a:solidFill>
                   <a:srgbClr val="53657D"/>
                 </a:solidFill>
@@ -6178,7 +6178,7 @@
           <a:lstStyle/>
           <a:p>
             <a:pPr algn="l">
-              <a:defRPr sz="1000" b="0">
+              <a:defRPr sz="900" b="0">
                 <a:solidFill>
                   <a:srgbClr val="72D4E8"/>
                 </a:solidFill>
@@ -6367,7 +6367,7 @@
           <a:lstStyle/>
           <a:p>
             <a:pPr algn="l">
-              <a:defRPr sz="1000" b="0">
+              <a:defRPr sz="900" b="0">
                 <a:solidFill>
                   <a:srgbClr val="53657D"/>
                 </a:solidFill>
@@ -7518,21 +7518,525 @@
               </a:defRPr>
             </a:pPr>
             <a:r>
-              <a:t>Every AI trade is placed under oath</a:t>
-            </a:r>
-          </a:p>
-        </p:txBody>
-      </p:sp>
-      <p:sp>
-        <p:nvSpPr>
-          <p:cNvPr id="6" name="Rectangle 5"/>
+              <a:t>One scorecard. Two defensible decisions.</a:t>
+            </a:r>
+          </a:p>
+        </p:txBody>
+      </p:sp>
+      <p:sp>
+        <p:nvSpPr>
+          <p:cNvPr id="6" name="TextBox 5"/>
+          <p:cNvSpPr txBox="1"/>
+          <p:nvPr/>
+        </p:nvSpPr>
+        <p:spPr>
+          <a:xfrm>
+            <a:off x="621792" y="1847088"/>
+            <a:ext cx="10698480" cy="502920"/>
+          </a:xfrm>
+          <a:prstGeom prst="rect">
+            <a:avLst/>
+          </a:prstGeom>
+          <a:noFill/>
+        </p:spPr>
+        <p:txBody>
+          <a:bodyPr wrap="square" anchor="t">
+            <a:spAutoFit/>
+          </a:bodyPr>
+          <a:lstStyle/>
+          <a:p>
+            <a:pPr algn="l">
+              <a:defRPr sz="1500" b="0">
+                <a:solidFill>
+                  <a:srgbClr val="53657D"/>
+                </a:solidFill>
+                <a:latin typeface="Aptos"/>
+              </a:defRPr>
+            </a:pPr>
+            <a:r>
+              <a:t>Signal strength never gets to hide weak execution evidence.</a:t>
+            </a:r>
+          </a:p>
+        </p:txBody>
+      </p:sp>
+      <p:sp>
+        <p:nvSpPr>
+          <p:cNvPr id="7" name="Rectangle 6"/>
           <p:cNvSpPr/>
           <p:nvPr/>
         </p:nvSpPr>
         <p:spPr>
           <a:xfrm>
-            <a:off x="594360" y="2240280"/>
-            <a:ext cx="5394960" cy="3200400"/>
+            <a:off x="594360" y="2423160"/>
+            <a:ext cx="2487168" cy="1188720"/>
+          </a:xfrm>
+          <a:prstGeom prst="rect">
+            <a:avLst/>
+          </a:prstGeom>
+          <a:solidFill>
+            <a:srgbClr val="F2F7FB"/>
+          </a:solidFill>
+          <a:ln>
+            <a:solidFill>
+              <a:srgbClr val="D5E0E9"/>
+            </a:solidFill>
+          </a:ln>
+        </p:spPr>
+        <p:style>
+          <a:lnRef idx="1">
+            <a:schemeClr val="accent1"/>
+          </a:lnRef>
+          <a:fillRef idx="3">
+            <a:schemeClr val="accent1"/>
+          </a:fillRef>
+          <a:effectRef idx="2">
+            <a:schemeClr val="accent1"/>
+          </a:effectRef>
+          <a:fontRef idx="minor">
+            <a:schemeClr val="lt1"/>
+          </a:fontRef>
+        </p:style>
+        <p:txBody>
+          <a:bodyPr rtlCol="0" anchor="ctr"/>
+          <a:lstStyle/>
+          <a:p>
+            <a:pPr algn="ctr"/>
+          </a:p>
+        </p:txBody>
+      </p:sp>
+      <p:sp>
+        <p:nvSpPr>
+          <p:cNvPr id="8" name="TextBox 7"/>
+          <p:cNvSpPr txBox="1"/>
+          <p:nvPr/>
+        </p:nvSpPr>
+        <p:spPr>
+          <a:xfrm>
+            <a:off x="777240" y="2633472"/>
+            <a:ext cx="2121408" cy="411480"/>
+          </a:xfrm>
+          <a:prstGeom prst="rect">
+            <a:avLst/>
+          </a:prstGeom>
+          <a:noFill/>
+        </p:spPr>
+        <p:txBody>
+          <a:bodyPr wrap="square" anchor="t">
+            <a:spAutoFit/>
+          </a:bodyPr>
+          <a:lstStyle/>
+          <a:p>
+            <a:pPr algn="ctr">
+              <a:defRPr sz="2400" b="1">
+                <a:solidFill>
+                  <a:srgbClr val="071D49"/>
+                </a:solidFill>
+                <a:latin typeface="Aptos"/>
+              </a:defRPr>
+            </a:pPr>
+            <a:r>
+              <a:t>85</a:t>
+            </a:r>
+          </a:p>
+        </p:txBody>
+      </p:sp>
+      <p:sp>
+        <p:nvSpPr>
+          <p:cNvPr id="9" name="TextBox 8"/>
+          <p:cNvSpPr txBox="1"/>
+          <p:nvPr/>
+        </p:nvSpPr>
+        <p:spPr>
+          <a:xfrm>
+            <a:off x="777240" y="3127248"/>
+            <a:ext cx="2121408" cy="228600"/>
+          </a:xfrm>
+          <a:prstGeom prst="rect">
+            <a:avLst/>
+          </a:prstGeom>
+          <a:noFill/>
+        </p:spPr>
+        <p:txBody>
+          <a:bodyPr wrap="square" anchor="t">
+            <a:spAutoFit/>
+          </a:bodyPr>
+          <a:lstStyle/>
+          <a:p>
+            <a:pPr algn="ctr">
+              <a:defRPr sz="1100" b="1">
+                <a:solidFill>
+                  <a:srgbClr val="53657D"/>
+                </a:solidFill>
+                <a:latin typeface="Aptos"/>
+              </a:defRPr>
+            </a:pPr>
+            <a:r>
+              <a:t>Signal quality</a:t>
+            </a:r>
+          </a:p>
+        </p:txBody>
+      </p:sp>
+      <p:sp>
+        <p:nvSpPr>
+          <p:cNvPr id="10" name="Rectangle 9"/>
+          <p:cNvSpPr/>
+          <p:nvPr/>
+        </p:nvSpPr>
+        <p:spPr>
+          <a:xfrm>
+            <a:off x="3355848" y="2423160"/>
+            <a:ext cx="2487168" cy="1188720"/>
+          </a:xfrm>
+          <a:prstGeom prst="rect">
+            <a:avLst/>
+          </a:prstGeom>
+          <a:solidFill>
+            <a:srgbClr val="F2F7FB"/>
+          </a:solidFill>
+          <a:ln>
+            <a:solidFill>
+              <a:srgbClr val="D5E0E9"/>
+            </a:solidFill>
+          </a:ln>
+        </p:spPr>
+        <p:style>
+          <a:lnRef idx="1">
+            <a:schemeClr val="accent1"/>
+          </a:lnRef>
+          <a:fillRef idx="3">
+            <a:schemeClr val="accent1"/>
+          </a:fillRef>
+          <a:effectRef idx="2">
+            <a:schemeClr val="accent1"/>
+          </a:effectRef>
+          <a:fontRef idx="minor">
+            <a:schemeClr val="lt1"/>
+          </a:fontRef>
+        </p:style>
+        <p:txBody>
+          <a:bodyPr rtlCol="0" anchor="ctr"/>
+          <a:lstStyle/>
+          <a:p>
+            <a:pPr algn="ctr"/>
+          </a:p>
+        </p:txBody>
+      </p:sp>
+      <p:sp>
+        <p:nvSpPr>
+          <p:cNvPr id="11" name="TextBox 10"/>
+          <p:cNvSpPr txBox="1"/>
+          <p:nvPr/>
+        </p:nvSpPr>
+        <p:spPr>
+          <a:xfrm>
+            <a:off x="3538728" y="2633472"/>
+            <a:ext cx="2121408" cy="411480"/>
+          </a:xfrm>
+          <a:prstGeom prst="rect">
+            <a:avLst/>
+          </a:prstGeom>
+          <a:noFill/>
+        </p:spPr>
+        <p:txBody>
+          <a:bodyPr wrap="square" anchor="t">
+            <a:spAutoFit/>
+          </a:bodyPr>
+          <a:lstStyle/>
+          <a:p>
+            <a:pPr algn="ctr">
+              <a:defRPr sz="2400" b="1">
+                <a:solidFill>
+                  <a:srgbClr val="071D49"/>
+                </a:solidFill>
+                <a:latin typeface="Aptos"/>
+              </a:defRPr>
+            </a:pPr>
+            <a:r>
+              <a:t>100</a:t>
+            </a:r>
+          </a:p>
+        </p:txBody>
+      </p:sp>
+      <p:sp>
+        <p:nvSpPr>
+          <p:cNvPr id="12" name="TextBox 11"/>
+          <p:cNvSpPr txBox="1"/>
+          <p:nvPr/>
+        </p:nvSpPr>
+        <p:spPr>
+          <a:xfrm>
+            <a:off x="3538728" y="3127248"/>
+            <a:ext cx="2121408" cy="228600"/>
+          </a:xfrm>
+          <a:prstGeom prst="rect">
+            <a:avLst/>
+          </a:prstGeom>
+          <a:noFill/>
+        </p:spPr>
+        <p:txBody>
+          <a:bodyPr wrap="square" anchor="t">
+            <a:spAutoFit/>
+          </a:bodyPr>
+          <a:lstStyle/>
+          <a:p>
+            <a:pPr algn="ctr">
+              <a:defRPr sz="1100" b="1">
+                <a:solidFill>
+                  <a:srgbClr val="53657D"/>
+                </a:solidFill>
+                <a:latin typeface="Aptos"/>
+              </a:defRPr>
+            </a:pPr>
+            <a:r>
+              <a:t>Decision stability</a:t>
+            </a:r>
+          </a:p>
+        </p:txBody>
+      </p:sp>
+      <p:sp>
+        <p:nvSpPr>
+          <p:cNvPr id="13" name="Rectangle 12"/>
+          <p:cNvSpPr/>
+          <p:nvPr/>
+        </p:nvSpPr>
+        <p:spPr>
+          <a:xfrm>
+            <a:off x="6117336" y="2423160"/>
+            <a:ext cx="2487168" cy="1188720"/>
+          </a:xfrm>
+          <a:prstGeom prst="rect">
+            <a:avLst/>
+          </a:prstGeom>
+          <a:solidFill>
+            <a:srgbClr val="F2F7FB"/>
+          </a:solidFill>
+          <a:ln>
+            <a:solidFill>
+              <a:srgbClr val="D5E0E9"/>
+            </a:solidFill>
+          </a:ln>
+        </p:spPr>
+        <p:style>
+          <a:lnRef idx="1">
+            <a:schemeClr val="accent1"/>
+          </a:lnRef>
+          <a:fillRef idx="3">
+            <a:schemeClr val="accent1"/>
+          </a:fillRef>
+          <a:effectRef idx="2">
+            <a:schemeClr val="accent1"/>
+          </a:effectRef>
+          <a:fontRef idx="minor">
+            <a:schemeClr val="lt1"/>
+          </a:fontRef>
+        </p:style>
+        <p:txBody>
+          <a:bodyPr rtlCol="0" anchor="ctr"/>
+          <a:lstStyle/>
+          <a:p>
+            <a:pPr algn="ctr"/>
+          </a:p>
+        </p:txBody>
+      </p:sp>
+      <p:sp>
+        <p:nvSpPr>
+          <p:cNvPr id="14" name="TextBox 13"/>
+          <p:cNvSpPr txBox="1"/>
+          <p:nvPr/>
+        </p:nvSpPr>
+        <p:spPr>
+          <a:xfrm>
+            <a:off x="6300216" y="2633472"/>
+            <a:ext cx="2121408" cy="411480"/>
+          </a:xfrm>
+          <a:prstGeom prst="rect">
+            <a:avLst/>
+          </a:prstGeom>
+          <a:noFill/>
+        </p:spPr>
+        <p:txBody>
+          <a:bodyPr wrap="square" anchor="t">
+            <a:spAutoFit/>
+          </a:bodyPr>
+          <a:lstStyle/>
+          <a:p>
+            <a:pPr algn="ctr">
+              <a:defRPr sz="2400" b="1">
+                <a:solidFill>
+                  <a:srgbClr val="071D49"/>
+                </a:solidFill>
+                <a:latin typeface="Aptos"/>
+              </a:defRPr>
+            </a:pPr>
+            <a:r>
+              <a:t>93</a:t>
+            </a:r>
+          </a:p>
+        </p:txBody>
+      </p:sp>
+      <p:sp>
+        <p:nvSpPr>
+          <p:cNvPr id="15" name="TextBox 14"/>
+          <p:cNvSpPr txBox="1"/>
+          <p:nvPr/>
+        </p:nvSpPr>
+        <p:spPr>
+          <a:xfrm>
+            <a:off x="6300216" y="3127248"/>
+            <a:ext cx="2121408" cy="228600"/>
+          </a:xfrm>
+          <a:prstGeom prst="rect">
+            <a:avLst/>
+          </a:prstGeom>
+          <a:noFill/>
+        </p:spPr>
+        <p:txBody>
+          <a:bodyPr wrap="square" anchor="t">
+            <a:spAutoFit/>
+          </a:bodyPr>
+          <a:lstStyle/>
+          <a:p>
+            <a:pPr algn="ctr">
+              <a:defRPr sz="1100" b="1">
+                <a:solidFill>
+                  <a:srgbClr val="53657D"/>
+                </a:solidFill>
+                <a:latin typeface="Aptos"/>
+              </a:defRPr>
+            </a:pPr>
+            <a:r>
+              <a:t>Execution quality</a:t>
+            </a:r>
+          </a:p>
+        </p:txBody>
+      </p:sp>
+      <p:sp>
+        <p:nvSpPr>
+          <p:cNvPr id="16" name="Rectangle 15"/>
+          <p:cNvSpPr/>
+          <p:nvPr/>
+        </p:nvSpPr>
+        <p:spPr>
+          <a:xfrm>
+            <a:off x="8878824" y="2423160"/>
+            <a:ext cx="2487168" cy="1188720"/>
+          </a:xfrm>
+          <a:prstGeom prst="rect">
+            <a:avLst/>
+          </a:prstGeom>
+          <a:solidFill>
+            <a:srgbClr val="F2F7FB"/>
+          </a:solidFill>
+          <a:ln>
+            <a:solidFill>
+              <a:srgbClr val="D5E0E9"/>
+            </a:solidFill>
+          </a:ln>
+        </p:spPr>
+        <p:style>
+          <a:lnRef idx="1">
+            <a:schemeClr val="accent1"/>
+          </a:lnRef>
+          <a:fillRef idx="3">
+            <a:schemeClr val="accent1"/>
+          </a:fillRef>
+          <a:effectRef idx="2">
+            <a:schemeClr val="accent1"/>
+          </a:effectRef>
+          <a:fontRef idx="minor">
+            <a:schemeClr val="lt1"/>
+          </a:fontRef>
+        </p:style>
+        <p:txBody>
+          <a:bodyPr rtlCol="0" anchor="ctr"/>
+          <a:lstStyle/>
+          <a:p>
+            <a:pPr algn="ctr"/>
+          </a:p>
+        </p:txBody>
+      </p:sp>
+      <p:sp>
+        <p:nvSpPr>
+          <p:cNvPr id="17" name="TextBox 16"/>
+          <p:cNvSpPr txBox="1"/>
+          <p:nvPr/>
+        </p:nvSpPr>
+        <p:spPr>
+          <a:xfrm>
+            <a:off x="9061704" y="2633472"/>
+            <a:ext cx="2121408" cy="411480"/>
+          </a:xfrm>
+          <a:prstGeom prst="rect">
+            <a:avLst/>
+          </a:prstGeom>
+          <a:noFill/>
+        </p:spPr>
+        <p:txBody>
+          <a:bodyPr wrap="square" anchor="t">
+            <a:spAutoFit/>
+          </a:bodyPr>
+          <a:lstStyle/>
+          <a:p>
+            <a:pPr algn="ctr">
+              <a:defRPr sz="2400" b="1">
+                <a:solidFill>
+                  <a:srgbClr val="071D49"/>
+                </a:solidFill>
+                <a:latin typeface="Aptos"/>
+              </a:defRPr>
+            </a:pPr>
+            <a:r>
+              <a:t>Pending</a:t>
+            </a:r>
+          </a:p>
+        </p:txBody>
+      </p:sp>
+      <p:sp>
+        <p:nvSpPr>
+          <p:cNvPr id="18" name="TextBox 17"/>
+          <p:cNvSpPr txBox="1"/>
+          <p:nvPr/>
+        </p:nvSpPr>
+        <p:spPr>
+          <a:xfrm>
+            <a:off x="9061704" y="3127248"/>
+            <a:ext cx="2121408" cy="228600"/>
+          </a:xfrm>
+          <a:prstGeom prst="rect">
+            <a:avLst/>
+          </a:prstGeom>
+          <a:noFill/>
+        </p:spPr>
+        <p:txBody>
+          <a:bodyPr wrap="square" anchor="t">
+            <a:spAutoFit/>
+          </a:bodyPr>
+          <a:lstStyle/>
+          <a:p>
+            <a:pPr algn="ctr">
+              <a:defRPr sz="1100" b="1">
+                <a:solidFill>
+                  <a:srgbClr val="53657D"/>
+                </a:solidFill>
+                <a:latin typeface="Aptos"/>
+              </a:defRPr>
+            </a:pPr>
+            <a:r>
+              <a:t>Outcome evidence</a:t>
+            </a:r>
+          </a:p>
+        </p:txBody>
+      </p:sp>
+      <p:sp>
+        <p:nvSpPr>
+          <p:cNvPr id="19" name="Rectangle 18"/>
+          <p:cNvSpPr/>
+          <p:nvPr/>
+        </p:nvSpPr>
+        <p:spPr>
+          <a:xfrm>
+            <a:off x="594360" y="3977639"/>
+            <a:ext cx="5349240" cy="1261872"/>
           </a:xfrm>
           <a:prstGeom prst="rect">
             <a:avLst/>
@@ -7570,14 +8074,14 @@
       </p:sp>
       <p:sp>
         <p:nvSpPr>
-          <p:cNvPr id="7" name="TextBox 6"/>
-          <p:cNvSpPr txBox="1"/>
-          <p:nvPr/>
-        </p:nvSpPr>
-        <p:spPr>
-          <a:xfrm>
-            <a:off x="914400" y="2606040"/>
-            <a:ext cx="4754880" cy="274320"/>
+          <p:cNvPr id="20" name="TextBox 19"/>
+          <p:cNvSpPr txBox="1"/>
+          <p:nvPr/>
+        </p:nvSpPr>
+        <p:spPr>
+          <a:xfrm>
+            <a:off x="868680" y="4224528"/>
+            <a:ext cx="2011680" cy="228600"/>
           </a:xfrm>
           <a:prstGeom prst="rect">
             <a:avLst/>
@@ -7599,38 +8103,35 @@
               </a:defRPr>
             </a:pPr>
             <a:r>
-              <a:t>BEFORE THE OUTCOME</a:t>
-            </a:r>
-          </a:p>
-        </p:txBody>
-      </p:sp>
-      <p:sp>
-        <p:nvSpPr>
-          <p:cNvPr id="8" name="TextBox 7"/>
-          <p:cNvSpPr txBox="1"/>
-          <p:nvPr/>
-        </p:nvSpPr>
-        <p:spPr>
-          <a:xfrm>
-            <a:off x="914400" y="3154680"/>
-            <a:ext cx="4709160" cy="1691640"/>
-          </a:xfrm>
-          <a:prstGeom prst="rect">
-            <a:avLst/>
-          </a:prstGeom>
-          <a:noFill/>
-        </p:spPr>
-        <p:txBody>
-          <a:bodyPr wrap="square">
-            <a:spAutoFit/>
-          </a:bodyPr>
-          <a:lstStyle/>
-          <a:p>
-            <a:pPr>
-              <a:spcAft>
-                <a:spcPts val="1400"/>
-              </a:spcAft>
-              <a:defRPr sz="1600">
+              <a:t>AUTHORIZED REPLAY</a:t>
+            </a:r>
+          </a:p>
+        </p:txBody>
+      </p:sp>
+      <p:sp>
+        <p:nvSpPr>
+          <p:cNvPr id="21" name="TextBox 20"/>
+          <p:cNvSpPr txBox="1"/>
+          <p:nvPr/>
+        </p:nvSpPr>
+        <p:spPr>
+          <a:xfrm>
+            <a:off x="868680" y="4599432"/>
+            <a:ext cx="4480560" cy="274320"/>
+          </a:xfrm>
+          <a:prstGeom prst="rect">
+            <a:avLst/>
+          </a:prstGeom>
+          <a:noFill/>
+        </p:spPr>
+        <p:txBody>
+          <a:bodyPr wrap="square" anchor="t">
+            <a:spAutoFit/>
+          </a:bodyPr>
+          <a:lstStyle/>
+          <a:p>
+            <a:pPr algn="l">
+              <a:defRPr sz="1700" b="1">
                 <a:solidFill>
                   <a:srgbClr val="FFFFFF"/>
                 </a:solidFill>
@@ -7638,53 +8139,21 @@
               </a:defRPr>
             </a:pPr>
             <a:r>
-              <a:t>•  Decision Replay reconstructs only evidence known at decision time</a:t>
-            </a:r>
-          </a:p>
-          <a:p>
-            <a:pPr>
-              <a:spcAft>
-                <a:spcPts val="1400"/>
-              </a:spcAft>
-              <a:defRPr sz="1600">
-                <a:solidFill>
-                  <a:srgbClr val="FFFFFF"/>
-                </a:solidFill>
-                <a:latin typeface="Aptos"/>
-              </a:defRPr>
-            </a:pPr>
-            <a:r>
-              <a:t>•  Adversarial review challenges the thesis before authorization</a:t>
-            </a:r>
-          </a:p>
-          <a:p>
-            <a:pPr>
-              <a:spcAft>
-                <a:spcPts val="1400"/>
-              </a:spcAft>
-              <a:defRPr sz="1600">
-                <a:solidFill>
-                  <a:srgbClr val="FFFFFF"/>
-                </a:solidFill>
-                <a:latin typeface="Aptos"/>
-              </a:defRPr>
-            </a:pPr>
-            <a:r>
-              <a:t>•  SHA-256 contract exposes any post-outcome rewriting</a:t>
-            </a:r>
-          </a:p>
-        </p:txBody>
-      </p:sp>
-      <p:sp>
-        <p:nvSpPr>
-          <p:cNvPr id="9" name="Rectangle 8"/>
+              <a:t>All deterministic gates passed</a:t>
+            </a:r>
+          </a:p>
+        </p:txBody>
+      </p:sp>
+      <p:sp>
+        <p:nvSpPr>
+          <p:cNvPr id="22" name="Rectangle 21"/>
           <p:cNvSpPr/>
           <p:nvPr/>
         </p:nvSpPr>
         <p:spPr>
           <a:xfrm>
-            <a:off x="6199632" y="2240280"/>
-            <a:ext cx="5394960" cy="3200400"/>
+            <a:off x="6199632" y="3977639"/>
+            <a:ext cx="5349240" cy="1261872"/>
           </a:xfrm>
           <a:prstGeom prst="rect">
             <a:avLst/>
@@ -7722,14 +8191,14 @@
       </p:sp>
       <p:sp>
         <p:nvSpPr>
-          <p:cNvPr id="10" name="TextBox 9"/>
-          <p:cNvSpPr txBox="1"/>
-          <p:nvPr/>
-        </p:nvSpPr>
-        <p:spPr>
-          <a:xfrm>
-            <a:off x="6519672" y="2606040"/>
-            <a:ext cx="4754880" cy="274320"/>
+          <p:cNvPr id="23" name="TextBox 22"/>
+          <p:cNvSpPr txBox="1"/>
+          <p:nvPr/>
+        </p:nvSpPr>
+        <p:spPr>
+          <a:xfrm>
+            <a:off x="6473952" y="4224528"/>
+            <a:ext cx="2103120" cy="228600"/>
           </a:xfrm>
           <a:prstGeom prst="rect">
             <a:avLst/>
@@ -7751,38 +8220,35 @@
               </a:defRPr>
             </a:pPr>
             <a:r>
-              <a:t>AFTER THE OUTCOME</a:t>
-            </a:r>
-          </a:p>
-        </p:txBody>
-      </p:sp>
-      <p:sp>
-        <p:nvSpPr>
-          <p:cNvPr id="11" name="TextBox 10"/>
-          <p:cNvSpPr txBox="1"/>
-          <p:nvPr/>
-        </p:nvSpPr>
-        <p:spPr>
-          <a:xfrm>
-            <a:off x="6519672" y="3154680"/>
-            <a:ext cx="4709160" cy="1691640"/>
-          </a:xfrm>
-          <a:prstGeom prst="rect">
-            <a:avLst/>
-          </a:prstGeom>
-          <a:noFill/>
-        </p:spPr>
-        <p:txBody>
-          <a:bodyPr wrap="square">
-            <a:spAutoFit/>
-          </a:bodyPr>
-          <a:lstStyle/>
-          <a:p>
-            <a:pPr>
-              <a:spcAft>
-                <a:spcPts val="1400"/>
-              </a:spcAft>
-              <a:defRPr sz="1600">
+              <a:t>LIVE CLOUD EVIDENCE</a:t>
+            </a:r>
+          </a:p>
+        </p:txBody>
+      </p:sp>
+      <p:sp>
+        <p:nvSpPr>
+          <p:cNvPr id="24" name="TextBox 23"/>
+          <p:cNvSpPr txBox="1"/>
+          <p:nvPr/>
+        </p:nvSpPr>
+        <p:spPr>
+          <a:xfrm>
+            <a:off x="6473952" y="4599432"/>
+            <a:ext cx="4526280" cy="274320"/>
+          </a:xfrm>
+          <a:prstGeom prst="rect">
+            <a:avLst/>
+          </a:prstGeom>
+          <a:noFill/>
+        </p:spPr>
+        <p:txBody>
+          <a:bodyPr wrap="square" anchor="t">
+            <a:spAutoFit/>
+          </a:bodyPr>
+          <a:lstStyle/>
+          <a:p>
+            <a:pPr algn="l">
+              <a:defRPr sz="1700" b="1">
                 <a:solidFill>
                   <a:srgbClr val="071D49"/>
                 </a:solidFill>
@@ -7790,46 +8256,50 @@
               </a:defRPr>
             </a:pPr>
             <a:r>
-              <a:t>•  Alpaca Greeks drive transparent scenario stress</a:t>
-            </a:r>
-          </a:p>
-          <a:p>
-            <a:pPr>
-              <a:spcAft>
-                <a:spcPts val="1400"/>
-              </a:spcAft>
-              <a:defRPr sz="1600">
-                <a:solidFill>
-                  <a:srgbClr val="071D49"/>
-                </a:solidFill>
-                <a:latin typeface="Aptos"/>
-              </a:defRPr>
-            </a:pPr>
-            <a:r>
-              <a:t>•  Agent, inverse and cash comparisons reduce storytelling</a:t>
-            </a:r>
-          </a:p>
-          <a:p>
-            <a:pPr>
-              <a:spcAft>
-                <a:spcPts val="1400"/>
-              </a:spcAft>
-              <a:defRPr sz="1600">
-                <a:solidFill>
-                  <a:srgbClr val="071D49"/>
-                </a:solidFill>
-                <a:latin typeface="Aptos"/>
-              </a:defRPr>
-            </a:pPr>
-            <a:r>
-              <a:t>•  Portable evidence receipt lets judges verify the proof chain</a:t>
-            </a:r>
-          </a:p>
-        </p:txBody>
-      </p:sp>
-      <p:sp>
-        <p:nvSpPr>
-          <p:cNvPr id="12" name="TextBox 11"/>
+              <a:t>ABSTAIN · 14 of 15 gates passed</a:t>
+            </a:r>
+          </a:p>
+        </p:txBody>
+      </p:sp>
+      <p:sp>
+        <p:nvSpPr>
+          <p:cNvPr id="25" name="TextBox 24"/>
+          <p:cNvSpPr txBox="1"/>
+          <p:nvPr/>
+        </p:nvSpPr>
+        <p:spPr>
+          <a:xfrm>
+            <a:off x="685800" y="5650992"/>
+            <a:ext cx="10698480" cy="228600"/>
+          </a:xfrm>
+          <a:prstGeom prst="rect">
+            <a:avLst/>
+          </a:prstGeom>
+          <a:noFill/>
+        </p:spPr>
+        <p:txBody>
+          <a:bodyPr wrap="square" anchor="t">
+            <a:spAutoFit/>
+          </a:bodyPr>
+          <a:lstStyle/>
+          <a:p>
+            <a:pPr algn="ctr">
+              <a:defRPr sz="1100" b="1">
+                <a:solidFill>
+                  <a:srgbClr val="53657D"/>
+                </a:solidFill>
+                <a:latin typeface="Aptos"/>
+              </a:defRPr>
+            </a:pPr>
+            <a:r>
+              <a:t>CS-20260831-66AAE940 · sealed receipt · zero broker mutations</a:t>
+            </a:r>
+          </a:p>
+        </p:txBody>
+      </p:sp>
+      <p:sp>
+        <p:nvSpPr>
+          <p:cNvPr id="26" name="TextBox 25"/>
           <p:cNvSpPr txBox="1"/>
           <p:nvPr/>
         </p:nvSpPr>
@@ -7865,7 +8335,7 @@
       </p:sp>
       <p:sp>
         <p:nvSpPr>
-          <p:cNvPr id="13" name="TextBox 12"/>
+          <p:cNvPr id="27" name="TextBox 26"/>
           <p:cNvSpPr txBox="1"/>
           <p:nvPr/>
         </p:nvSpPr>
@@ -8169,7 +8639,7 @@
         <p:spPr>
           <a:xfrm>
             <a:off x="868680" y="2560320"/>
-            <a:ext cx="1005840" cy="228600"/>
+            <a:ext cx="1143000" cy="256032"/>
           </a:xfrm>
           <a:prstGeom prst="rect">
             <a:avLst/>
@@ -8183,7 +8653,7 @@
           <a:lstStyle/>
           <a:p>
             <a:pPr algn="l">
-              <a:defRPr sz="1300" b="1">
+              <a:defRPr sz="1100" b="1">
                 <a:solidFill>
                   <a:srgbClr val="071D49"/>
                 </a:solidFill>
@@ -8204,8 +8674,8 @@
         </p:nvSpPr>
         <p:spPr>
           <a:xfrm>
-            <a:off x="1920240" y="2560320"/>
-            <a:ext cx="1783080" cy="457200"/>
+            <a:off x="2103120" y="2560320"/>
+            <a:ext cx="1600200" cy="457200"/>
           </a:xfrm>
           <a:prstGeom prst="rect">
             <a:avLst/>
@@ -8219,7 +8689,7 @@
           <a:lstStyle/>
           <a:p>
             <a:pPr algn="l">
-              <a:defRPr sz="1300" b="0">
+              <a:defRPr sz="1100" b="0">
                 <a:solidFill>
                   <a:srgbClr val="53657D"/>
                 </a:solidFill>
@@ -8331,7 +8801,7 @@
         <p:spPr>
           <a:xfrm>
             <a:off x="4636008" y="2560320"/>
-            <a:ext cx="1005840" cy="228600"/>
+            <a:ext cx="1143000" cy="256032"/>
           </a:xfrm>
           <a:prstGeom prst="rect">
             <a:avLst/>
@@ -8345,7 +8815,7 @@
           <a:lstStyle/>
           <a:p>
             <a:pPr algn="l">
-              <a:defRPr sz="1300" b="1">
+              <a:defRPr sz="1100" b="1">
                 <a:solidFill>
                   <a:srgbClr val="071D49"/>
                 </a:solidFill>
@@ -8353,7 +8823,7 @@
               </a:defRPr>
             </a:pPr>
             <a:r>
-              <a:t>Broker</a:t>
+              <a:t>Cloud watch</a:t>
             </a:r>
           </a:p>
         </p:txBody>
@@ -8366,8 +8836,8 @@
         </p:nvSpPr>
         <p:spPr>
           <a:xfrm>
-            <a:off x="5687568" y="2560320"/>
-            <a:ext cx="1783080" cy="457200"/>
+            <a:off x="5870448" y="2560320"/>
+            <a:ext cx="1600200" cy="457200"/>
           </a:xfrm>
           <a:prstGeom prst="rect">
             <a:avLst/>
@@ -8381,7 +8851,7 @@
           <a:lstStyle/>
           <a:p>
             <a:pPr algn="l">
-              <a:defRPr sz="1300" b="0">
+              <a:defRPr sz="1100" b="0">
                 <a:solidFill>
                   <a:srgbClr val="53657D"/>
                 </a:solidFill>
@@ -8389,7 +8859,7 @@
               </a:defRPr>
             </a:pPr>
             <a:r>
-              <a:t>Exact paper endpoint</a:t>
+              <a:t>Observe only</a:t>
             </a:r>
           </a:p>
         </p:txBody>
@@ -8493,7 +8963,7 @@
         <p:spPr>
           <a:xfrm>
             <a:off x="8403336" y="2560320"/>
-            <a:ext cx="1005840" cy="228600"/>
+            <a:ext cx="1143000" cy="256032"/>
           </a:xfrm>
           <a:prstGeom prst="rect">
             <a:avLst/>
@@ -8507,7 +8977,7 @@
           <a:lstStyle/>
           <a:p>
             <a:pPr algn="l">
-              <a:defRPr sz="1300" b="1">
+              <a:defRPr sz="1100" b="1">
                 <a:solidFill>
                   <a:srgbClr val="071D49"/>
                 </a:solidFill>
@@ -8528,8 +8998,8 @@
         </p:nvSpPr>
         <p:spPr>
           <a:xfrm>
-            <a:off x="9454896" y="2560320"/>
-            <a:ext cx="1783080" cy="457200"/>
+            <a:off x="9637776" y="2560320"/>
+            <a:ext cx="1600200" cy="457200"/>
           </a:xfrm>
           <a:prstGeom prst="rect">
             <a:avLst/>
@@ -8543,7 +9013,7 @@
           <a:lstStyle/>
           <a:p>
             <a:pPr algn="l">
-              <a:defRPr sz="1300" b="0">
+              <a:defRPr sz="1100" b="0">
                 <a:solidFill>
                   <a:srgbClr val="53657D"/>
                 </a:solidFill>
@@ -8655,7 +9125,7 @@
         <p:spPr>
           <a:xfrm>
             <a:off x="868680" y="3886200"/>
-            <a:ext cx="1005840" cy="228600"/>
+            <a:ext cx="1143000" cy="256032"/>
           </a:xfrm>
           <a:prstGeom prst="rect">
             <a:avLst/>
@@ -8669,7 +9139,7 @@
           <a:lstStyle/>
           <a:p>
             <a:pPr algn="l">
-              <a:defRPr sz="1300" b="1">
+              <a:defRPr sz="1100" b="1">
                 <a:solidFill>
                   <a:srgbClr val="071D49"/>
                 </a:solidFill>
@@ -8690,8 +9160,8 @@
         </p:nvSpPr>
         <p:spPr>
           <a:xfrm>
-            <a:off x="1920240" y="3886200"/>
-            <a:ext cx="1783080" cy="457200"/>
+            <a:off x="2103120" y="3886200"/>
+            <a:ext cx="1600200" cy="457200"/>
           </a:xfrm>
           <a:prstGeom prst="rect">
             <a:avLst/>
@@ -8705,7 +9175,7 @@
           <a:lstStyle/>
           <a:p>
             <a:pPr algn="l">
-              <a:defRPr sz="1300" b="0">
+              <a:defRPr sz="1100" b="0">
                 <a:solidFill>
                   <a:srgbClr val="53657D"/>
                 </a:solidFill>
@@ -8817,7 +9287,7 @@
         <p:spPr>
           <a:xfrm>
             <a:off x="4636008" y="3886200"/>
-            <a:ext cx="1005840" cy="228600"/>
+            <a:ext cx="1143000" cy="256032"/>
           </a:xfrm>
           <a:prstGeom prst="rect">
             <a:avLst/>
@@ -8831,7 +9301,7 @@
           <a:lstStyle/>
           <a:p>
             <a:pPr algn="l">
-              <a:defRPr sz="1300" b="1">
+              <a:defRPr sz="1100" b="1">
                 <a:solidFill>
                   <a:srgbClr val="071D49"/>
                 </a:solidFill>
@@ -8852,8 +9322,8 @@
         </p:nvSpPr>
         <p:spPr>
           <a:xfrm>
-            <a:off x="5687568" y="3886200"/>
-            <a:ext cx="1783080" cy="457200"/>
+            <a:off x="5870448" y="3886200"/>
+            <a:ext cx="1600200" cy="457200"/>
           </a:xfrm>
           <a:prstGeom prst="rect">
             <a:avLst/>
@@ -8867,7 +9337,7 @@
           <a:lstStyle/>
           <a:p>
             <a:pPr algn="l">
-              <a:defRPr sz="1300" b="0">
+              <a:defRPr sz="1100" b="0">
                 <a:solidFill>
                   <a:srgbClr val="53657D"/>
                 </a:solidFill>
@@ -8979,7 +9449,7 @@
         <p:spPr>
           <a:xfrm>
             <a:off x="8403336" y="3886200"/>
-            <a:ext cx="1005840" cy="228600"/>
+            <a:ext cx="1143000" cy="256032"/>
           </a:xfrm>
           <a:prstGeom prst="rect">
             <a:avLst/>
@@ -8993,7 +9463,7 @@
           <a:lstStyle/>
           <a:p>
             <a:pPr algn="l">
-              <a:defRPr sz="1300" b="1">
+              <a:defRPr sz="1100" b="1">
                 <a:solidFill>
                   <a:srgbClr val="071D49"/>
                 </a:solidFill>
@@ -9014,8 +9484,8 @@
         </p:nvSpPr>
         <p:spPr>
           <a:xfrm>
-            <a:off x="9454896" y="3886200"/>
-            <a:ext cx="1783080" cy="457200"/>
+            <a:off x="9637776" y="3886200"/>
+            <a:ext cx="1600200" cy="457200"/>
           </a:xfrm>
           <a:prstGeom prst="rect">
             <a:avLst/>
@@ -9029,7 +9499,7 @@
           <a:lstStyle/>
           <a:p>
             <a:pPr algn="l">
-              <a:defRPr sz="1300" b="0">
+              <a:defRPr sz="1100" b="0">
                 <a:solidFill>
                   <a:srgbClr val="53657D"/>
                 </a:solidFill>
@@ -10229,7 +10699,7 @@
               </a:defRPr>
             </a:pPr>
             <a:r>
-              <a:t>31</a:t>
+              <a:t>35</a:t>
             </a:r>
           </a:p>
         </p:txBody>
@@ -10301,7 +10771,7 @@
               </a:defRPr>
             </a:pPr>
             <a:r>
-              <a:t>6/6</a:t>
+              <a:t>85/100</a:t>
             </a:r>
           </a:p>
         </p:txBody>
@@ -10337,7 +10807,7 @@
               </a:defRPr>
             </a:pPr>
             <a:r>
-              <a:t>Greeks coverage</a:t>
+              <a:t>live signal quality</a:t>
             </a:r>
           </a:p>
         </p:txBody>
@@ -10373,7 +10843,7 @@
               </a:defRPr>
             </a:pPr>
             <a:r>
-              <a:t>5 days</a:t>
+              <a:t>14/15</a:t>
             </a:r>
           </a:p>
         </p:txBody>
@@ -10409,7 +10879,7 @@
               </a:defRPr>
             </a:pPr>
             <a:r>
-              <a:t>scoring horizon</a:t>
+              <a:t>risk gates passed</a:t>
             </a:r>
           </a:p>
         </p:txBody>

</xml_diff>

<commit_message>
Keep unscoreable directions honest across evaluation
</commit_message>
<xml_diff>
--- a/submission/CrossSignal-Hackathon-Pitch-Final.pptx
+++ b/submission/CrossSignal-Hackathon-Pitch-Final.pptx
@@ -999,7 +999,7 @@
           <a:lstStyle/>
           <a:p>
             <a:r>
-              <a:t>Close on verified evidence: thirty-five tests pass in GitHub, the scheduled cloud watcher sealed a live contract, and the system abstained because one risk gate failed. CrossSignal makes AI trading decisions inspectable, challengeable, reproducible, and measurable. Invite judges to open the live application, repository, and Actions evidence artifact.</a:t>
+              <a:t>Close on verified evidence: thirty-eight tests pass in GitHub, the scheduled cloud watcher sealed a live contract, and the system abstained because one risk gate failed. CrossSignal makes AI trading decisions inspectable, challengeable, reproducible, and measurable. Invite judges to open the live application, repository, and Actions evidence artifact.</a:t>
             </a:r>
           </a:p>
         </p:txBody>
@@ -10699,7 +10699,7 @@
               </a:defRPr>
             </a:pPr>
             <a:r>
-              <a:t>35</a:t>
+              <a:t>38</a:t>
             </a:r>
           </a:p>
         </p:txBody>

</xml_diff>

<commit_message>
Pin verified MCP stack and preserve failure evidence
</commit_message>
<xml_diff>
--- a/submission/CrossSignal-Hackathon-Pitch-Final.pptx
+++ b/submission/CrossSignal-Hackathon-Pitch-Final.pptx
@@ -999,7 +999,7 @@
           <a:lstStyle/>
           <a:p>
             <a:r>
-              <a:t>Close on verified evidence: thirty-eight tests pass in GitHub, the scheduled cloud watcher sealed a live contract, and the system abstained because one risk gate failed. CrossSignal makes AI trading decisions inspectable, challengeable, reproducible, and measurable. Invite judges to open the live application, repository, and Actions evidence artifact.</a:t>
+              <a:t>Close on verified evidence: thirty-nine tests pass in GitHub, the scheduled cloud watcher sealed a live contract, and the system abstained because one risk gate failed. CrossSignal makes AI trading decisions inspectable, challengeable, reproducible, and measurable. Invite judges to open the live application, repository, and Actions evidence artifact.</a:t>
             </a:r>
           </a:p>
         </p:txBody>
@@ -10699,7 +10699,7 @@
               </a:defRPr>
             </a:pPr>
             <a:r>
-              <a:t>38</a:t>
+              <a:t>39</a:t>
             </a:r>
           </a:p>
         </p:txBody>

</xml_diff>

<commit_message>
Regenerate pitch deck with real, current evidence
Replaces the stale CS-20260831-66AAE940 contract, 39-test count, and an
implied-but-nonexistent "authorized" example with real evidence from the
dedicated hackathon account:

- Contract CS-20260901-4B6D4392, sealed 2026-09-01 against account
  PA3PDTUDIXDU
- Real scorecard: signal quality 82, decision stability 100 (10/10 real
  perturbations), execution quality 67 (4/6 gates), outcome pending
- 43 tests, not 39
- The proof slide's two examples are now the public sanitized replay and
  the live dedicated-account evidence, rather than an authorized case that
  doesn't currently exist
</commit_message>
<xml_diff>
--- a/submission/CrossSignal-Hackathon-Pitch-Final.pptx
+++ b/submission/CrossSignal-Hackathon-Pitch-Final.pptx
@@ -789,7 +789,7 @@
           <a:lstStyle/>
           <a:p>
             <a:r>
-              <a:t>This is the key proof slide. The same policy evaluates both cases. The authorized replay shows the complete path when every gate passes. The live GitHub Evidence Watch contract scored 85 for signal and 100 for stability, but execution quality was 93 because one of fifteen gates failed—so the correct autonomous decision was abstention. Outcome evidence remains pending until the sealed horizon matures.</a:t>
+              <a:t>This is the key proof slide, drawn from a live cycle against the dedicated hackathon paper account on September 1st. Signal quality scored 82 and decision stability 100 across ten real perturbations, but execution quality was 67 because two of six deterministic checks failed -- live-data integrity and post-falsification confidence -- so the correct autonomous decision was abstention. Outcome evidence remains pending until the sealed horizon matures.</a:t>
             </a:r>
           </a:p>
         </p:txBody>
@@ -999,7 +999,7 @@
           <a:lstStyle/>
           <a:p>
             <a:r>
-              <a:t>Close on verified evidence: thirty-nine tests pass in GitHub, the scheduled cloud watcher sealed a live contract, and the system abstained because one risk gate failed. CrossSignal makes AI trading decisions inspectable, challengeable, reproducible, and measurable. Invite judges to open the live application, repository, and Actions evidence artifact.</a:t>
+              <a:t>Close on verified evidence: forty-three tests pass in GitHub, a live cycle against the dedicated hackathon paper account sealed a real contract on September 1st, and the system abstained because two of six deterministic checks failed. CrossSignal makes AI trading decisions inspectable, challengeable, reproducible, and measurable. Invite judges to open the live application, repository, and dedicated account PA3PDTUDIXDU.</a:t>
             </a:r>
           </a:p>
         </p:txBody>
@@ -7518,7 +7518,7 @@
               </a:defRPr>
             </a:pPr>
             <a:r>
-              <a:t>One scorecard. Two defensible decisions.</a:t>
+              <a:t>One scorecard. A decision that defends itself.</a:t>
             </a:r>
           </a:p>
         </p:txBody>
@@ -7635,7 +7635,7 @@
               </a:defRPr>
             </a:pPr>
             <a:r>
-              <a:t>85</a:t>
+              <a:t>82</a:t>
             </a:r>
           </a:p>
         </p:txBody>
@@ -7869,7 +7869,7 @@
               </a:defRPr>
             </a:pPr>
             <a:r>
-              <a:t>93</a:t>
+              <a:t>67</a:t>
             </a:r>
           </a:p>
         </p:txBody>
@@ -8103,7 +8103,7 @@
               </a:defRPr>
             </a:pPr>
             <a:r>
-              <a:t>AUTHORIZED REPLAY</a:t>
+              <a:t>PUBLIC JUDGE REPLAY</a:t>
             </a:r>
           </a:p>
         </p:txBody>
@@ -8139,7 +8139,7 @@
               </a:defRPr>
             </a:pPr>
             <a:r>
-              <a:t>All deterministic gates passed</a:t>
+              <a:t>Sanitized case, credential-free</a:t>
             </a:r>
           </a:p>
         </p:txBody>
@@ -8220,7 +8220,7 @@
               </a:defRPr>
             </a:pPr>
             <a:r>
-              <a:t>LIVE CLOUD EVIDENCE</a:t>
+              <a:t>LIVE DEDICATED ACCOUNT</a:t>
             </a:r>
           </a:p>
         </p:txBody>
@@ -8256,7 +8256,7 @@
               </a:defRPr>
             </a:pPr>
             <a:r>
-              <a:t>ABSTAIN · 14 of 15 gates passed</a:t>
+              <a:t>ABSTAIN · 4 of 6 gates passed</a:t>
             </a:r>
           </a:p>
         </p:txBody>
@@ -8292,7 +8292,7 @@
               </a:defRPr>
             </a:pPr>
             <a:r>
-              <a:t>CS-20260831-66AAE940 · sealed receipt · zero broker mutations</a:t>
+              <a:t>CS-20260901-4B6D4392 · account PA3PDTUDIXDU · sealed receipt · zero broker mutations</a:t>
             </a:r>
           </a:p>
         </p:txBody>
@@ -10699,7 +10699,7 @@
               </a:defRPr>
             </a:pPr>
             <a:r>
-              <a:t>39</a:t>
+              <a:t>43</a:t>
             </a:r>
           </a:p>
         </p:txBody>
@@ -10771,7 +10771,7 @@
               </a:defRPr>
             </a:pPr>
             <a:r>
-              <a:t>85/100</a:t>
+              <a:t>82/100</a:t>
             </a:r>
           </a:p>
         </p:txBody>
@@ -10843,7 +10843,7 @@
               </a:defRPr>
             </a:pPr>
             <a:r>
-              <a:t>14/15</a:t>
+              <a:t>4/6</a:t>
             </a:r>
           </a:p>
         </p:txBody>

</xml_diff>

<commit_message>
Refresh pitch deck with current evidence, fix name and video transitions
Deck: 46 tests (was 43), latest live contract CS-20260902-BF9B142D
(5 of 6 gates passed, missed authorization by a single confidence
point) replacing the Sep 1 evidence.

Video script: closing card and title card now read "Omobolaji Adeyan"
in full instead of the first name alone; the live-app screen
recording segment now fades in/out like every other clip in the
sequence instead of cutting in and out abruptly.

Co-Authored-By: Claude Sonnet 5 <noreply@anthropic.com>
</commit_message>
<xml_diff>
--- a/submission/CrossSignal-Hackathon-Pitch-Final.pptx
+++ b/submission/CrossSignal-Hackathon-Pitch-Final.pptx
@@ -789,7 +789,7 @@
           <a:lstStyle/>
           <a:p>
             <a:r>
-              <a:t>This is the key proof slide, drawn from a live cycle against the dedicated hackathon paper account on September 1st. Signal quality scored 82 and decision stability 100 across ten real perturbations, but execution quality was 67 because two of six deterministic checks failed -- live-data integrity and post-falsification confidence -- so the correct autonomous decision was abstention. Outcome evidence remains pending until the sealed horizon matures.</a:t>
+              <a:t>This is the key proof slide, drawn from the latest live cycle against the dedicated hackathon paper account on September 2nd. Signal quality scored 82 and decision stability 100 across ten real perturbations. Five of six deterministic execution checks passed -- every gate cleared except post-falsification confidence, which landed at 54 percent against a 55 percent minimum. One point short. That razor-close abstention is the point: CrossSignal does not round in its own favor. Outcome evidence remains pending until the sealed horizon matures.</a:t>
             </a:r>
           </a:p>
         </p:txBody>
@@ -999,7 +999,7 @@
           <a:lstStyle/>
           <a:p>
             <a:r>
-              <a:t>Close on verified evidence: forty-three tests pass in GitHub, a live cycle against the dedicated hackathon paper account sealed a real contract on September 1st, and the system abstained because two of six deterministic checks failed. CrossSignal makes AI trading decisions inspectable, challengeable, reproducible, and measurable. Invite judges to open the live application, repository, and dedicated account PA3PDTUDIXDU.</a:t>
+              <a:t>Close on verified evidence: forty-six tests pass in GitHub, a live cycle against the dedicated hackathon paper account sealed a real contract on September 2nd, and the system abstained by a single confidence point after five of six deterministic checks passed. CrossSignal makes AI trading decisions inspectable, challengeable, reproducible, and measurable. Invite judges to open the live application, repository, and dedicated account PA3PDTUDIXDU.</a:t>
             </a:r>
           </a:p>
         </p:txBody>
@@ -7869,7 +7869,7 @@
               </a:defRPr>
             </a:pPr>
             <a:r>
-              <a:t>67</a:t>
+              <a:t>83</a:t>
             </a:r>
           </a:p>
         </p:txBody>
@@ -8248,7 +8248,7 @@
           <a:lstStyle/>
           <a:p>
             <a:pPr algn="l">
-              <a:defRPr sz="1700" b="1">
+              <a:defRPr sz="1500" b="1">
                 <a:solidFill>
                   <a:srgbClr val="071D49"/>
                 </a:solidFill>
@@ -8256,7 +8256,7 @@
               </a:defRPr>
             </a:pPr>
             <a:r>
-              <a:t>ABSTAIN · 4 of 6 gates passed</a:t>
+              <a:t>ABSTAIN · missed by 1 point · 5 of 6 gates passed</a:t>
             </a:r>
           </a:p>
         </p:txBody>
@@ -8292,7 +8292,7 @@
               </a:defRPr>
             </a:pPr>
             <a:r>
-              <a:t>CS-20260901-4B6D4392 · account PA3PDTUDIXDU · sealed receipt · zero broker mutations</a:t>
+              <a:t>CS-20260902-BF9B142D · account PA3PDTUDIXDU · sealed receipt · zero broker mutations</a:t>
             </a:r>
           </a:p>
         </p:txBody>
@@ -10699,7 +10699,7 @@
               </a:defRPr>
             </a:pPr>
             <a:r>
-              <a:t>43</a:t>
+              <a:t>46</a:t>
             </a:r>
           </a:p>
         </p:txBody>
@@ -10843,7 +10843,7 @@
               </a:defRPr>
             </a:pPr>
             <a:r>
-              <a:t>4/6</a:t>
+              <a:t>5/6</a:t>
             </a:r>
           </a:p>
         </p:txBody>

</xml_diff>

<commit_message>
Add position lifecycle manager, refresh submission artifacts
Adds agent/position_manager.py (governed exit lifecycle: broker
reconciliation, quote-freshness gate, four exit rules, atomic
multi-leg reversal) plus scripts/manage_positions.py CLI and its
test suite (59 tests total, up from 46). Regenerates the pitch deck,
one-page write-up, and research report from source and refreshes
REQUIREMENTS_AUDIT.md, SUBMISSION.md, SMOKE_TEST.md, and the final
video script to reflect the new capability and the tenth live cycle.

Co-Authored-By: Claude Sonnet 5 <noreply@anthropic.com>
</commit_message>
<xml_diff>
--- a/submission/CrossSignal-Hackathon-Pitch-Final.pptx
+++ b/submission/CrossSignal-Hackathon-Pitch-Final.pptx
@@ -579,7 +579,7 @@
           <a:lstStyle/>
           <a:p>
             <a:r>
-              <a:t>Markets transmit information at different speeds. CrossSignal addresses fragmentation, weak AI accountability, and the absence of honest forward scoring.</a:t>
+              <a:t>Markets transmit information at different speeds. CrossSignal addresses fragmented evidence, weak AI accountability, and the common gap between governed entry and disciplined exit.</a:t>
             </a:r>
           </a:p>
         </p:txBody>
@@ -719,7 +719,7 @@
           <a:lstStyle/>
           <a:p>
             <a:r>
-              <a:t>The official Alpaca MCP server powers sponsor-native market evidence and the paper execution lifecycle. Claude reasons, but deterministic code controls broker access.</a:t>
+              <a:t>The official Alpaca MCP server powers market evidence and the paper lifecycle. Claude reasons, but deterministic code controls entry and exit. Every spread persists thresholds fixed at entry. Before an exit, CrossSignal reconciles broker legs, rejects stale quote timestamps, atomically claims the transition, and reverses both legs under a deterministic client order ID.</a:t>
             </a:r>
           </a:p>
         </p:txBody>
@@ -789,7 +789,7 @@
           <a:lstStyle/>
           <a:p>
             <a:r>
-              <a:t>This is the key proof slide, drawn from the latest live cycle against the dedicated hackathon paper account on September 2nd. Signal quality scored 82 and decision stability 100 across ten real perturbations. Five of six deterministic execution checks passed -- every gate cleared except post-falsification confidence, which landed at 54 percent against a 55 percent minimum. One point short. That razor-close abstention is the point: CrossSignal does not round in its own favor. Outcome evidence remains pending until the sealed horizon matures.</a:t>
+              <a:t>This is the key proof slide from the September 3 unattended Evidence Watch. Confidence cleared at 56 percent and all six base gates passed. The all-leg option preflight then found zero displayed volume on the weakest leg and a 93.33 percent relative bid-ask spread, against limits of ten contracts and 25 percent. Only 13 of 15 checks passed, so the agent abstained. The run occurred after the regular options session; it did not queue a non-executable order. The dedicated account therefore has no trade P&amp;L to claim.</a:t>
             </a:r>
           </a:p>
         </p:txBody>
@@ -999,7 +999,7 @@
           <a:lstStyle/>
           <a:p>
             <a:r>
-              <a:t>Close on verified evidence: forty-six tests pass in GitHub, a live cycle against the dedicated hackathon paper account sealed a real contract on September 2nd, and the system abstained by a single confidence point after five of six deterministic checks passed. CrossSignal makes AI trading decisions inspectable, challengeable, reproducible, and measurable. Invite judges to open the live application, repository, and dedicated account PA3PDTUDIXDU.</a:t>
+              <a:t>Close on verified evidence: fifty-nine tests pass, including profit, loss, time, expiry, broker-reconciliation, quote-freshness, uncertain-submission locking, market-clock, atomic-close, audit, and idempotency tests. Ten connected cycles are sealed against the dedicated account; the latest rejected non-executable after-hours quotes. The account remains at 100,000 dollars with no orders or positions, so there is no P&amp;L claim and the lifecycle replay is illustrative rather than broker fill evidence.</a:t>
             </a:r>
           </a:p>
         </p:txBody>
@@ -4962,7 +4962,7 @@
               </a:defRPr>
             </a:pPr>
             <a:r>
-              <a:t>Unmeasured</a:t>
+              <a:t>Unmanaged</a:t>
             </a:r>
           </a:p>
         </p:txBody>
@@ -4998,7 +4998,7 @@
               </a:defRPr>
             </a:pPr>
             <a:r>
-              <a:t>Most agents do not precommit a forecast and later score whether it was right.</a:t>
+              <a:t>Many agents govern entry but provide no explicit profit, loss, time or expiry exit policy.</a:t>
             </a:r>
           </a:p>
         </p:txBody>
@@ -7147,7 +7147,7 @@
               <a:spcAft>
                 <a:spcPts val="1400"/>
               </a:spcAft>
-              <a:defRPr sz="1500">
+              <a:defRPr sz="1300">
                 <a:solidFill>
                   <a:srgbClr val="071D49"/>
                 </a:solidFill>
@@ -7163,7 +7163,7 @@
               <a:spcAft>
                 <a:spcPts val="1400"/>
               </a:spcAft>
-              <a:defRPr sz="1500">
+              <a:defRPr sz="1300">
                 <a:solidFill>
                   <a:srgbClr val="071D49"/>
                 </a:solidFill>
@@ -7171,7 +7171,7 @@
               </a:defRPr>
             </a:pPr>
             <a:r>
-              <a:t>•  Multi-leg paper orders</a:t>
+              <a:t>•  Take-profit and stop-loss</a:t>
             </a:r>
           </a:p>
           <a:p>
@@ -7179,7 +7179,7 @@
               <a:spcAft>
                 <a:spcPts val="1400"/>
               </a:spcAft>
-              <a:defRPr sz="1500">
+              <a:defRPr sz="1300">
                 <a:solidFill>
                   <a:srgbClr val="071D49"/>
                 </a:solidFill>
@@ -7187,7 +7187,7 @@
               </a:defRPr>
             </a:pPr>
             <a:r>
-              <a:t>•  Fill reconciliation</a:t>
+              <a:t>•  Time and expiry exits</a:t>
             </a:r>
           </a:p>
           <a:p>
@@ -7195,7 +7195,7 @@
               <a:spcAft>
                 <a:spcPts val="1400"/>
               </a:spcAft>
-              <a:defRPr sz="1500">
+              <a:defRPr sz="1300">
                 <a:solidFill>
                   <a:srgbClr val="071D49"/>
                 </a:solidFill>
@@ -7203,7 +7203,7 @@
               </a:defRPr>
             </a:pPr>
             <a:r>
-              <a:t>•  Explicit recovery state</a:t>
+              <a:t>•  Fresh quotes, broker reconciliation, atomic close</a:t>
             </a:r>
           </a:p>
         </p:txBody>
@@ -7752,7 +7752,7 @@
               </a:defRPr>
             </a:pPr>
             <a:r>
-              <a:t>100</a:t>
+              <a:t>90</a:t>
             </a:r>
           </a:p>
         </p:txBody>
@@ -7869,7 +7869,7 @@
               </a:defRPr>
             </a:pPr>
             <a:r>
-              <a:t>83</a:t>
+              <a:t>87</a:t>
             </a:r>
           </a:p>
         </p:txBody>
@@ -8256,7 +8256,7 @@
               </a:defRPr>
             </a:pPr>
             <a:r>
-              <a:t>ABSTAIN · missed by 1 point · 5 of 6 gates passed</a:t>
+              <a:t>ABSTAIN · 13 of 15 checks · quotes not executable</a:t>
             </a:r>
           </a:p>
         </p:txBody>
@@ -8292,7 +8292,7 @@
               </a:defRPr>
             </a:pPr>
             <a:r>
-              <a:t>CS-20260902-BF9B142D · account PA3PDTUDIXDU · sealed receipt · zero broker mutations</a:t>
+              <a:t>CS-20260903-5C194F65 · PA3PDTUDIXDU · 0 orders · 0 positions · no P&amp;L claim</a:t>
             </a:r>
           </a:p>
         </p:txBody>
@@ -9248,11 +9248,11 @@
             <a:avLst/>
           </a:prstGeom>
           <a:solidFill>
-            <a:srgbClr val="C67E00"/>
+            <a:srgbClr val="1E8E53"/>
           </a:solidFill>
           <a:ln>
             <a:solidFill>
-              <a:srgbClr val="C67E00"/>
+              <a:srgbClr val="1E8E53"/>
             </a:solidFill>
           </a:ln>
         </p:spPr>
@@ -9309,7 +9309,7 @@
               </a:defRPr>
             </a:pPr>
             <a:r>
-              <a:t>Recovery</a:t>
+              <a:t>Exit state</a:t>
             </a:r>
           </a:p>
         </p:txBody>
@@ -9345,7 +9345,7 @@
               </a:defRPr>
             </a:pPr>
             <a:r>
-              <a:t>Explicit approval</a:t>
+              <a:t>No duplicate closes</a:t>
             </a:r>
           </a:p>
         </p:txBody>
@@ -9471,7 +9471,7 @@
               </a:defRPr>
             </a:pPr>
             <a:r>
-              <a:t>News</a:t>
+              <a:t>Recovery</a:t>
             </a:r>
           </a:p>
         </p:txBody>
@@ -9507,7 +9507,7 @@
               </a:defRPr>
             </a:pPr>
             <a:r>
-              <a:t>Untrusted context</a:t>
+              <a:t>Explicit approval</a:t>
             </a:r>
           </a:p>
         </p:txBody>
@@ -10699,7 +10699,7 @@
               </a:defRPr>
             </a:pPr>
             <a:r>
-              <a:t>46</a:t>
+              <a:t>59</a:t>
             </a:r>
           </a:p>
         </p:txBody>
@@ -10771,7 +10771,7 @@
               </a:defRPr>
             </a:pPr>
             <a:r>
-              <a:t>82/100</a:t>
+              <a:t>4</a:t>
             </a:r>
           </a:p>
         </p:txBody>
@@ -10807,7 +10807,7 @@
               </a:defRPr>
             </a:pPr>
             <a:r>
-              <a:t>live signal quality</a:t>
+              <a:t>sealed exit rules</a:t>
             </a:r>
           </a:p>
         </p:txBody>
@@ -10843,7 +10843,7 @@
               </a:defRPr>
             </a:pPr>
             <a:r>
-              <a:t>5/6</a:t>
+              <a:t>13/15</a:t>
             </a:r>
           </a:p>
         </p:txBody>
@@ -10879,7 +10879,7 @@
               </a:defRPr>
             </a:pPr>
             <a:r>
-              <a:t>risk gates passed</a:t>
+              <a:t>latest full checks</a:t>
             </a:r>
           </a:p>
         </p:txBody>
@@ -11157,11 +11157,11 @@
               </a:defRPr>
             </a:pPr>
             <a:r>
-              <a:t>CrossSignal does not merely recommend a trade.</a:t>
+              <a:t>CrossSignal proves when a trade deserves entry—</a:t>
             </a:r>
             <a:br/>
             <a:r>
-              <a:t>It proves whether the trade deserves authorization.</a:t>
+              <a:t>and manages exactly how it exits.</a:t>
             </a:r>
           </a:p>
         </p:txBody>

</xml_diff>

<commit_message>
Fix missing cover image on pitch deck title slide
COVER was defined but never placed -- the rounded-rectangle frame in
the top-right of slide 1 rendered as an empty navy box. Now inserts
the cover art, center-cropped to fill the square frame.

Co-Authored-By: Claude Sonnet 5 <noreply@anthropic.com>
</commit_message>
<xml_diff>
--- a/submission/CrossSignal-Hackathon-Pitch-Final.pptx
+++ b/submission/CrossSignal-Hackathon-Pitch-Final.pptx
@@ -4297,9 +4297,34 @@
           </a:p>
         </p:txBody>
       </p:sp>
-      <p:sp>
-        <p:nvSpPr>
-          <p:cNvPr id="9" name="TextBox 8"/>
+      <p:pic>
+        <p:nvPicPr>
+          <p:cNvPr id="9" name="Picture 8" descr="crosssignal-hackathon-cover.png"/>
+          <p:cNvPicPr>
+            <a:picLocks noChangeAspect="1"/>
+          </p:cNvPicPr>
+          <p:nvPr/>
+        </p:nvPicPr>
+        <p:blipFill>
+          <a:blip r:embed="rId2"/>
+          <a:srcRect l="21860" r="21860"/>
+          <a:stretch>
+            <a:fillRect/>
+          </a:stretch>
+        </p:blipFill>
+        <p:spPr>
+          <a:xfrm>
+            <a:off x="9692640" y="274320"/>
+            <a:ext cx="2505456" cy="2505456"/>
+          </a:xfrm>
+          <a:prstGeom prst="rect">
+            <a:avLst/>
+          </a:prstGeom>
+        </p:spPr>
+      </p:pic>
+      <p:sp>
+        <p:nvSpPr>
+          <p:cNvPr id="10" name="TextBox 9"/>
           <p:cNvSpPr txBox="1"/>
           <p:nvPr/>
         </p:nvSpPr>
@@ -4335,7 +4360,7 @@
       </p:sp>
       <p:sp>
         <p:nvSpPr>
-          <p:cNvPr id="10" name="TextBox 9"/>
+          <p:cNvPr id="11" name="TextBox 10"/>
           <p:cNvSpPr txBox="1"/>
           <p:nvPr/>
         </p:nvSpPr>

</xml_diff>

<commit_message>
Elevate CrossSignal brand and judge experience
</commit_message>
<xml_diff>
--- a/submission/CrossSignal-Hackathon-Pitch-Final.pptx
+++ b/submission/CrossSignal-Hackathon-Pitch-Final.pptx
@@ -4005,301 +4005,9 @@
         <p:nvPr/>
       </p:nvGrpSpPr>
       <p:grpSpPr/>
-      <p:sp>
-        <p:nvSpPr>
-          <p:cNvPr id="2" name="Rectangle 1"/>
-          <p:cNvSpPr/>
-          <p:nvPr/>
-        </p:nvSpPr>
-        <p:spPr>
-          <a:xfrm>
-            <a:off x="0" y="0"/>
-            <a:ext cx="12191695" cy="6858000"/>
-          </a:xfrm>
-          <a:prstGeom prst="rect">
-            <a:avLst/>
-          </a:prstGeom>
-          <a:solidFill>
-            <a:srgbClr val="071D49"/>
-          </a:solidFill>
-          <a:ln>
-            <a:solidFill>
-              <a:srgbClr val="071D49"/>
-            </a:solidFill>
-          </a:ln>
-        </p:spPr>
-        <p:style>
-          <a:lnRef idx="1">
-            <a:schemeClr val="accent1"/>
-          </a:lnRef>
-          <a:fillRef idx="3">
-            <a:schemeClr val="accent1"/>
-          </a:fillRef>
-          <a:effectRef idx="2">
-            <a:schemeClr val="accent1"/>
-          </a:effectRef>
-          <a:fontRef idx="minor">
-            <a:schemeClr val="lt1"/>
-          </a:fontRef>
-        </p:style>
-        <p:txBody>
-          <a:bodyPr rtlCol="0" anchor="ctr"/>
-          <a:lstStyle/>
-          <a:p>
-            <a:pPr algn="ctr"/>
-          </a:p>
-        </p:txBody>
-      </p:sp>
-      <p:sp>
-        <p:nvSpPr>
-          <p:cNvPr id="3" name="Rectangle 2"/>
-          <p:cNvSpPr/>
-          <p:nvPr/>
-        </p:nvSpPr>
-        <p:spPr>
-          <a:xfrm>
-            <a:off x="640080" y="640080"/>
-            <a:ext cx="54864" cy="384048"/>
-          </a:xfrm>
-          <a:prstGeom prst="rect">
-            <a:avLst/>
-          </a:prstGeom>
-          <a:solidFill>
-            <a:srgbClr val="19B5D8"/>
-          </a:solidFill>
-          <a:ln>
-            <a:solidFill>
-              <a:srgbClr val="19B5D8"/>
-            </a:solidFill>
-          </a:ln>
-        </p:spPr>
-        <p:style>
-          <a:lnRef idx="1">
-            <a:schemeClr val="accent1"/>
-          </a:lnRef>
-          <a:fillRef idx="3">
-            <a:schemeClr val="accent1"/>
-          </a:fillRef>
-          <a:effectRef idx="2">
-            <a:schemeClr val="accent1"/>
-          </a:effectRef>
-          <a:fontRef idx="minor">
-            <a:schemeClr val="lt1"/>
-          </a:fontRef>
-        </p:style>
-        <p:txBody>
-          <a:bodyPr rtlCol="0" anchor="ctr"/>
-          <a:lstStyle/>
-          <a:p>
-            <a:pPr algn="ctr"/>
-          </a:p>
-        </p:txBody>
-      </p:sp>
-      <p:sp>
-        <p:nvSpPr>
-          <p:cNvPr id="4" name="TextBox 3"/>
-          <p:cNvSpPr txBox="1"/>
-          <p:nvPr/>
-        </p:nvSpPr>
-        <p:spPr>
-          <a:xfrm>
-            <a:off x="822960" y="667512"/>
-            <a:ext cx="6583680" cy="320040"/>
-          </a:xfrm>
-          <a:prstGeom prst="rect">
-            <a:avLst/>
-          </a:prstGeom>
-          <a:noFill/>
-        </p:spPr>
-        <p:txBody>
-          <a:bodyPr wrap="square" anchor="t">
-            <a:spAutoFit/>
-          </a:bodyPr>
-          <a:lstStyle/>
-          <a:p>
-            <a:pPr algn="l">
-              <a:defRPr sz="1100" b="1">
-                <a:solidFill>
-                  <a:srgbClr val="72D4E8"/>
-                </a:solidFill>
-                <a:latin typeface="Aptos"/>
-              </a:defRPr>
-            </a:pPr>
-            <a:r>
-              <a:t>DECISION INTELLIGENCE FOR CROSS-MARKET TRADING</a:t>
-            </a:r>
-          </a:p>
-        </p:txBody>
-      </p:sp>
-      <p:sp>
-        <p:nvSpPr>
-          <p:cNvPr id="5" name="TextBox 4"/>
-          <p:cNvSpPr txBox="1"/>
-          <p:nvPr/>
-        </p:nvSpPr>
-        <p:spPr>
-          <a:xfrm>
-            <a:off x="658368" y="1417320"/>
-            <a:ext cx="8046720" cy="2057400"/>
-          </a:xfrm>
-          <a:prstGeom prst="rect">
-            <a:avLst/>
-          </a:prstGeom>
-          <a:noFill/>
-        </p:spPr>
-        <p:txBody>
-          <a:bodyPr wrap="square" anchor="t">
-            <a:spAutoFit/>
-          </a:bodyPr>
-          <a:lstStyle/>
-          <a:p>
-            <a:pPr algn="l">
-              <a:defRPr sz="4200" b="1">
-                <a:solidFill>
-                  <a:srgbClr val="FFFFFF"/>
-                </a:solidFill>
-                <a:latin typeface="Aptos Display"/>
-              </a:defRPr>
-            </a:pPr>
-            <a:r>
-              <a:t>Markets disagree.</a:t>
-            </a:r>
-            <a:br/>
-            <a:r>
-              <a:t>We trade the gap.</a:t>
-            </a:r>
-          </a:p>
-        </p:txBody>
-      </p:sp>
-      <p:sp>
-        <p:nvSpPr>
-          <p:cNvPr id="6" name="TextBox 5"/>
-          <p:cNvSpPr txBox="1"/>
-          <p:nvPr/>
-        </p:nvSpPr>
-        <p:spPr>
-          <a:xfrm>
-            <a:off x="685800" y="3822191"/>
-            <a:ext cx="7498079" cy="685800"/>
-          </a:xfrm>
-          <a:prstGeom prst="rect">
-            <a:avLst/>
-          </a:prstGeom>
-          <a:noFill/>
-        </p:spPr>
-        <p:txBody>
-          <a:bodyPr wrap="square" anchor="t">
-            <a:spAutoFit/>
-          </a:bodyPr>
-          <a:lstStyle/>
-          <a:p>
-            <a:pPr algn="l">
-              <a:defRPr sz="2000" b="0">
-                <a:solidFill>
-                  <a:srgbClr val="72D4E8"/>
-                </a:solidFill>
-                <a:latin typeface="Aptos"/>
-              </a:defRPr>
-            </a:pPr>
-            <a:r>
-              <a:t>An auditable AI trading agent that challenges, governs and scores every decision.</a:t>
-            </a:r>
-          </a:p>
-        </p:txBody>
-      </p:sp>
-      <p:sp>
-        <p:nvSpPr>
-          <p:cNvPr id="7" name="Rounded Rectangle 6"/>
-          <p:cNvSpPr/>
-          <p:nvPr/>
-        </p:nvSpPr>
-        <p:spPr>
-          <a:xfrm>
-            <a:off x="8869680" y="-548640"/>
-            <a:ext cx="4114800" cy="4114800"/>
-          </a:xfrm>
-          <a:prstGeom prst="roundRect">
-            <a:avLst/>
-          </a:prstGeom>
-          <a:solidFill>
-            <a:srgbClr val="19B5D8"/>
-          </a:solidFill>
-          <a:ln>
-            <a:solidFill>
-              <a:srgbClr val="19B5D8"/>
-            </a:solidFill>
-          </a:ln>
-        </p:spPr>
-        <p:style>
-          <a:lnRef idx="1">
-            <a:schemeClr val="accent1"/>
-          </a:lnRef>
-          <a:fillRef idx="3">
-            <a:schemeClr val="accent1"/>
-          </a:fillRef>
-          <a:effectRef idx="2">
-            <a:schemeClr val="accent1"/>
-          </a:effectRef>
-          <a:fontRef idx="minor">
-            <a:schemeClr val="lt1"/>
-          </a:fontRef>
-        </p:style>
-        <p:txBody>
-          <a:bodyPr rtlCol="0" anchor="ctr"/>
-          <a:lstStyle/>
-          <a:p>
-            <a:pPr algn="ctr"/>
-          </a:p>
-        </p:txBody>
-      </p:sp>
-      <p:sp>
-        <p:nvSpPr>
-          <p:cNvPr id="8" name="Rounded Rectangle 7"/>
-          <p:cNvSpPr/>
-          <p:nvPr/>
-        </p:nvSpPr>
-        <p:spPr>
-          <a:xfrm>
-            <a:off x="9528048" y="109728"/>
-            <a:ext cx="2834640" cy="2834640"/>
-          </a:xfrm>
-          <a:prstGeom prst="roundRect">
-            <a:avLst/>
-          </a:prstGeom>
-          <a:solidFill>
-            <a:srgbClr val="071D49"/>
-          </a:solidFill>
-          <a:ln>
-            <a:solidFill>
-              <a:srgbClr val="071D49"/>
-            </a:solidFill>
-          </a:ln>
-        </p:spPr>
-        <p:style>
-          <a:lnRef idx="1">
-            <a:schemeClr val="accent1"/>
-          </a:lnRef>
-          <a:fillRef idx="3">
-            <a:schemeClr val="accent1"/>
-          </a:fillRef>
-          <a:effectRef idx="2">
-            <a:schemeClr val="accent1"/>
-          </a:effectRef>
-          <a:fontRef idx="minor">
-            <a:schemeClr val="lt1"/>
-          </a:fontRef>
-        </p:style>
-        <p:txBody>
-          <a:bodyPr rtlCol="0" anchor="ctr"/>
-          <a:lstStyle/>
-          <a:p>
-            <a:pPr algn="ctr"/>
-          </a:p>
-        </p:txBody>
-      </p:sp>
       <p:pic>
         <p:nvPicPr>
-          <p:cNvPr id="9" name="Picture 8" descr="crosssignal-hackathon-cover.png"/>
+          <p:cNvPr id="2" name="Picture 1" descr="crosssignal-hackathon-cover.png"/>
           <p:cNvPicPr>
             <a:picLocks noChangeAspect="1"/>
           </p:cNvPicPr>
@@ -4307,93 +4015,20 @@
         </p:nvPicPr>
         <p:blipFill>
           <a:blip r:embed="rId2"/>
-          <a:srcRect l="21860" r="21860"/>
           <a:stretch>
             <a:fillRect/>
           </a:stretch>
         </p:blipFill>
         <p:spPr>
           <a:xfrm>
-            <a:off x="9692640" y="274320"/>
-            <a:ext cx="2505456" cy="2505456"/>
+            <a:off x="0" y="0"/>
+            <a:ext cx="12191695" cy="6858000"/>
           </a:xfrm>
           <a:prstGeom prst="rect">
             <a:avLst/>
           </a:prstGeom>
         </p:spPr>
       </p:pic>
-      <p:sp>
-        <p:nvSpPr>
-          <p:cNvPr id="10" name="TextBox 9"/>
-          <p:cNvSpPr txBox="1"/>
-          <p:nvPr/>
-        </p:nvSpPr>
-        <p:spPr>
-          <a:xfrm>
-            <a:off x="685800" y="5715000"/>
-            <a:ext cx="3657600" cy="365760"/>
-          </a:xfrm>
-          <a:prstGeom prst="rect">
-            <a:avLst/>
-          </a:prstGeom>
-          <a:noFill/>
-        </p:spPr>
-        <p:txBody>
-          <a:bodyPr wrap="square" anchor="t">
-            <a:spAutoFit/>
-          </a:bodyPr>
-          <a:lstStyle/>
-          <a:p>
-            <a:pPr algn="l">
-              <a:defRPr sz="1800" b="1">
-                <a:solidFill>
-                  <a:srgbClr val="FFFFFF"/>
-                </a:solidFill>
-                <a:latin typeface="Aptos"/>
-              </a:defRPr>
-            </a:pPr>
-            <a:r>
-              <a:t>CROSSSIGNAL</a:t>
-            </a:r>
-          </a:p>
-        </p:txBody>
-      </p:sp>
-      <p:sp>
-        <p:nvSpPr>
-          <p:cNvPr id="11" name="TextBox 10"/>
-          <p:cNvSpPr txBox="1"/>
-          <p:nvPr/>
-        </p:nvSpPr>
-        <p:spPr>
-          <a:xfrm>
-            <a:off x="685800" y="6126480"/>
-            <a:ext cx="4572000" cy="274320"/>
-          </a:xfrm>
-          <a:prstGeom prst="rect">
-            <a:avLst/>
-          </a:prstGeom>
-          <a:noFill/>
-        </p:spPr>
-        <p:txBody>
-          <a:bodyPr wrap="square" anchor="t">
-            <a:spAutoFit/>
-          </a:bodyPr>
-          <a:lstStyle/>
-          <a:p>
-            <a:pPr algn="l">
-              <a:defRPr sz="1200" b="0">
-                <a:solidFill>
-                  <a:srgbClr val="72D4E8"/>
-                </a:solidFill>
-                <a:latin typeface="Aptos"/>
-              </a:defRPr>
-            </a:pPr>
-            <a:r>
-              <a:t>Created by Omobolaji E Adeyan</a:t>
-            </a:r>
-          </a:p>
-        </p:txBody>
-      </p:sp>
     </p:spTree>
   </p:cSld>
   <p:clrMapOvr>
@@ -5028,15 +4663,39 @@
           </a:p>
         </p:txBody>
       </p:sp>
-      <p:sp>
-        <p:nvSpPr>
-          <p:cNvPr id="18" name="TextBox 17"/>
-          <p:cNvSpPr txBox="1"/>
-          <p:nvPr/>
-        </p:nvSpPr>
-        <p:spPr>
-          <a:xfrm>
-            <a:off x="594360" y="6473952"/>
+      <p:pic>
+        <p:nvPicPr>
+          <p:cNvPr id="18" name="Picture 17" descr="crosssignal-logo-mark.png"/>
+          <p:cNvPicPr>
+            <a:picLocks noChangeAspect="1"/>
+          </p:cNvPicPr>
+          <p:nvPr/>
+        </p:nvPicPr>
+        <p:blipFill>
+          <a:blip r:embed="rId2"/>
+          <a:stretch>
+            <a:fillRect/>
+          </a:stretch>
+        </p:blipFill>
+        <p:spPr>
+          <a:xfrm>
+            <a:off x="530352" y="6382512"/>
+            <a:ext cx="237744" cy="237744"/>
+          </a:xfrm>
+          <a:prstGeom prst="rect">
+            <a:avLst/>
+          </a:prstGeom>
+        </p:spPr>
+      </p:pic>
+      <p:sp>
+        <p:nvSpPr>
+          <p:cNvPr id="19" name="TextBox 18"/>
+          <p:cNvSpPr txBox="1"/>
+          <p:nvPr/>
+        </p:nvSpPr>
+        <p:spPr>
+          <a:xfrm>
+            <a:off x="822960" y="6473952"/>
             <a:ext cx="9875520" cy="182880"/>
           </a:xfrm>
           <a:prstGeom prst="rect">
@@ -5066,7 +4725,7 @@
       </p:sp>
       <p:sp>
         <p:nvSpPr>
-          <p:cNvPr id="19" name="TextBox 18"/>
+          <p:cNvPr id="20" name="TextBox 19"/>
           <p:cNvSpPr txBox="1"/>
           <p:nvPr/>
         </p:nvSpPr>
@@ -6486,15 +6145,39 @@
           </a:p>
         </p:txBody>
       </p:sp>
-      <p:sp>
-        <p:nvSpPr>
-          <p:cNvPr id="38" name="TextBox 37"/>
-          <p:cNvSpPr txBox="1"/>
-          <p:nvPr/>
-        </p:nvSpPr>
-        <p:spPr>
-          <a:xfrm>
-            <a:off x="594360" y="6473952"/>
+      <p:pic>
+        <p:nvPicPr>
+          <p:cNvPr id="38" name="Picture 37" descr="crosssignal-logo-mark.png"/>
+          <p:cNvPicPr>
+            <a:picLocks noChangeAspect="1"/>
+          </p:cNvPicPr>
+          <p:nvPr/>
+        </p:nvPicPr>
+        <p:blipFill>
+          <a:blip r:embed="rId2"/>
+          <a:stretch>
+            <a:fillRect/>
+          </a:stretch>
+        </p:blipFill>
+        <p:spPr>
+          <a:xfrm>
+            <a:off x="530352" y="6382512"/>
+            <a:ext cx="237744" cy="237744"/>
+          </a:xfrm>
+          <a:prstGeom prst="rect">
+            <a:avLst/>
+          </a:prstGeom>
+        </p:spPr>
+      </p:pic>
+      <p:sp>
+        <p:nvSpPr>
+          <p:cNvPr id="39" name="TextBox 38"/>
+          <p:cNvSpPr txBox="1"/>
+          <p:nvPr/>
+        </p:nvSpPr>
+        <p:spPr>
+          <a:xfrm>
+            <a:off x="822960" y="6473952"/>
             <a:ext cx="9875520" cy="182880"/>
           </a:xfrm>
           <a:prstGeom prst="rect">
@@ -6524,7 +6207,7 @@
       </p:sp>
       <p:sp>
         <p:nvSpPr>
-          <p:cNvPr id="39" name="TextBox 38"/>
+          <p:cNvPr id="40" name="TextBox 39"/>
           <p:cNvSpPr txBox="1"/>
           <p:nvPr/>
         </p:nvSpPr>
@@ -7305,15 +6988,39 @@
           </a:p>
         </p:txBody>
       </p:sp>
-      <p:sp>
-        <p:nvSpPr>
-          <p:cNvPr id="17" name="TextBox 16"/>
-          <p:cNvSpPr txBox="1"/>
-          <p:nvPr/>
-        </p:nvSpPr>
-        <p:spPr>
-          <a:xfrm>
-            <a:off x="594360" y="6473952"/>
+      <p:pic>
+        <p:nvPicPr>
+          <p:cNvPr id="17" name="Picture 16" descr="crosssignal-logo-mark.png"/>
+          <p:cNvPicPr>
+            <a:picLocks noChangeAspect="1"/>
+          </p:cNvPicPr>
+          <p:nvPr/>
+        </p:nvPicPr>
+        <p:blipFill>
+          <a:blip r:embed="rId2"/>
+          <a:stretch>
+            <a:fillRect/>
+          </a:stretch>
+        </p:blipFill>
+        <p:spPr>
+          <a:xfrm>
+            <a:off x="530352" y="6382512"/>
+            <a:ext cx="237744" cy="237744"/>
+          </a:xfrm>
+          <a:prstGeom prst="rect">
+            <a:avLst/>
+          </a:prstGeom>
+        </p:spPr>
+      </p:pic>
+      <p:sp>
+        <p:nvSpPr>
+          <p:cNvPr id="18" name="TextBox 17"/>
+          <p:cNvSpPr txBox="1"/>
+          <p:nvPr/>
+        </p:nvSpPr>
+        <p:spPr>
+          <a:xfrm>
+            <a:off x="822960" y="6473952"/>
             <a:ext cx="9875520" cy="182880"/>
           </a:xfrm>
           <a:prstGeom prst="rect">
@@ -7343,7 +7050,7 @@
       </p:sp>
       <p:sp>
         <p:nvSpPr>
-          <p:cNvPr id="18" name="TextBox 17"/>
+          <p:cNvPr id="19" name="TextBox 18"/>
           <p:cNvSpPr txBox="1"/>
           <p:nvPr/>
         </p:nvSpPr>
@@ -8322,15 +8029,39 @@
           </a:p>
         </p:txBody>
       </p:sp>
-      <p:sp>
-        <p:nvSpPr>
-          <p:cNvPr id="26" name="TextBox 25"/>
-          <p:cNvSpPr txBox="1"/>
-          <p:nvPr/>
-        </p:nvSpPr>
-        <p:spPr>
-          <a:xfrm>
-            <a:off x="594360" y="6473952"/>
+      <p:pic>
+        <p:nvPicPr>
+          <p:cNvPr id="26" name="Picture 25" descr="crosssignal-logo-mark.png"/>
+          <p:cNvPicPr>
+            <a:picLocks noChangeAspect="1"/>
+          </p:cNvPicPr>
+          <p:nvPr/>
+        </p:nvPicPr>
+        <p:blipFill>
+          <a:blip r:embed="rId2"/>
+          <a:stretch>
+            <a:fillRect/>
+          </a:stretch>
+        </p:blipFill>
+        <p:spPr>
+          <a:xfrm>
+            <a:off x="530352" y="6382512"/>
+            <a:ext cx="237744" cy="237744"/>
+          </a:xfrm>
+          <a:prstGeom prst="rect">
+            <a:avLst/>
+          </a:prstGeom>
+        </p:spPr>
+      </p:pic>
+      <p:sp>
+        <p:nvSpPr>
+          <p:cNvPr id="27" name="TextBox 26"/>
+          <p:cNvSpPr txBox="1"/>
+          <p:nvPr/>
+        </p:nvSpPr>
+        <p:spPr>
+          <a:xfrm>
+            <a:off x="822960" y="6473952"/>
             <a:ext cx="9875520" cy="182880"/>
           </a:xfrm>
           <a:prstGeom prst="rect">
@@ -8360,7 +8091,7 @@
       </p:sp>
       <p:sp>
         <p:nvSpPr>
-          <p:cNvPr id="27" name="TextBox 26"/>
+          <p:cNvPr id="28" name="TextBox 27"/>
           <p:cNvSpPr txBox="1"/>
           <p:nvPr/>
         </p:nvSpPr>
@@ -9618,15 +9349,39 @@
           </a:p>
         </p:txBody>
       </p:sp>
-      <p:sp>
-        <p:nvSpPr>
-          <p:cNvPr id="32" name="TextBox 31"/>
-          <p:cNvSpPr txBox="1"/>
-          <p:nvPr/>
-        </p:nvSpPr>
-        <p:spPr>
-          <a:xfrm>
-            <a:off x="594360" y="6473952"/>
+      <p:pic>
+        <p:nvPicPr>
+          <p:cNvPr id="32" name="Picture 31" descr="crosssignal-logo-mark.png"/>
+          <p:cNvPicPr>
+            <a:picLocks noChangeAspect="1"/>
+          </p:cNvPicPr>
+          <p:nvPr/>
+        </p:nvPicPr>
+        <p:blipFill>
+          <a:blip r:embed="rId2"/>
+          <a:stretch>
+            <a:fillRect/>
+          </a:stretch>
+        </p:blipFill>
+        <p:spPr>
+          <a:xfrm>
+            <a:off x="530352" y="6382512"/>
+            <a:ext cx="237744" cy="237744"/>
+          </a:xfrm>
+          <a:prstGeom prst="rect">
+            <a:avLst/>
+          </a:prstGeom>
+        </p:spPr>
+      </p:pic>
+      <p:sp>
+        <p:nvSpPr>
+          <p:cNvPr id="33" name="TextBox 32"/>
+          <p:cNvSpPr txBox="1"/>
+          <p:nvPr/>
+        </p:nvSpPr>
+        <p:spPr>
+          <a:xfrm>
+            <a:off x="822960" y="6473952"/>
             <a:ext cx="9875520" cy="182880"/>
           </a:xfrm>
           <a:prstGeom prst="rect">
@@ -9656,7 +9411,7 @@
       </p:sp>
       <p:sp>
         <p:nvSpPr>
-          <p:cNvPr id="33" name="TextBox 32"/>
+          <p:cNvPr id="34" name="TextBox 33"/>
           <p:cNvSpPr txBox="1"/>
           <p:nvPr/>
         </p:nvSpPr>
@@ -10482,15 +10237,39 @@
           </a:p>
         </p:txBody>
       </p:sp>
-      <p:sp>
-        <p:nvSpPr>
-          <p:cNvPr id="21" name="TextBox 20"/>
-          <p:cNvSpPr txBox="1"/>
-          <p:nvPr/>
-        </p:nvSpPr>
-        <p:spPr>
-          <a:xfrm>
-            <a:off x="594360" y="6473952"/>
+      <p:pic>
+        <p:nvPicPr>
+          <p:cNvPr id="21" name="Picture 20" descr="crosssignal-logo-mark.png"/>
+          <p:cNvPicPr>
+            <a:picLocks noChangeAspect="1"/>
+          </p:cNvPicPr>
+          <p:nvPr/>
+        </p:nvPicPr>
+        <p:blipFill>
+          <a:blip r:embed="rId2"/>
+          <a:stretch>
+            <a:fillRect/>
+          </a:stretch>
+        </p:blipFill>
+        <p:spPr>
+          <a:xfrm>
+            <a:off x="530352" y="6382512"/>
+            <a:ext cx="237744" cy="237744"/>
+          </a:xfrm>
+          <a:prstGeom prst="rect">
+            <a:avLst/>
+          </a:prstGeom>
+        </p:spPr>
+      </p:pic>
+      <p:sp>
+        <p:nvSpPr>
+          <p:cNvPr id="22" name="TextBox 21"/>
+          <p:cNvSpPr txBox="1"/>
+          <p:nvPr/>
+        </p:nvSpPr>
+        <p:spPr>
+          <a:xfrm>
+            <a:off x="822960" y="6473952"/>
             <a:ext cx="9875520" cy="182880"/>
           </a:xfrm>
           <a:prstGeom prst="rect">
@@ -10520,7 +10299,7 @@
       </p:sp>
       <p:sp>
         <p:nvSpPr>
-          <p:cNvPr id="22" name="TextBox 21"/>
+          <p:cNvPr id="23" name="TextBox 22"/>
           <p:cNvSpPr txBox="1"/>
           <p:nvPr/>
         </p:nvSpPr>
@@ -10617,15 +10396,39 @@
           </a:p>
         </p:txBody>
       </p:sp>
-      <p:sp>
-        <p:nvSpPr>
-          <p:cNvPr id="3" name="TextBox 2"/>
-          <p:cNvSpPr txBox="1"/>
-          <p:nvPr/>
-        </p:nvSpPr>
-        <p:spPr>
-          <a:xfrm>
-            <a:off x="685800" y="640080"/>
+      <p:pic>
+        <p:nvPicPr>
+          <p:cNvPr id="3" name="Picture 2" descr="crosssignal-logo-mark.png"/>
+          <p:cNvPicPr>
+            <a:picLocks noChangeAspect="1"/>
+          </p:cNvPicPr>
+          <p:nvPr/>
+        </p:nvPicPr>
+        <p:blipFill>
+          <a:blip r:embed="rId2"/>
+          <a:stretch>
+            <a:fillRect/>
+          </a:stretch>
+        </p:blipFill>
+        <p:spPr>
+          <a:xfrm>
+            <a:off x="621792" y="402336"/>
+            <a:ext cx="475488" cy="475488"/>
+          </a:xfrm>
+          <a:prstGeom prst="rect">
+            <a:avLst/>
+          </a:prstGeom>
+        </p:spPr>
+      </p:pic>
+      <p:sp>
+        <p:nvSpPr>
+          <p:cNvPr id="4" name="TextBox 3"/>
+          <p:cNvSpPr txBox="1"/>
+          <p:nvPr/>
+        </p:nvSpPr>
+        <p:spPr>
+          <a:xfrm>
+            <a:off x="1188720" y="585216"/>
             <a:ext cx="3657600" cy="274320"/>
           </a:xfrm>
           <a:prstGeom prst="rect">
@@ -10655,7 +10458,7 @@
       </p:sp>
       <p:sp>
         <p:nvSpPr>
-          <p:cNvPr id="4" name="TextBox 3"/>
+          <p:cNvPr id="5" name="TextBox 4"/>
           <p:cNvSpPr txBox="1"/>
           <p:nvPr/>
         </p:nvSpPr>
@@ -10695,7 +10498,7 @@
       </p:sp>
       <p:sp>
         <p:nvSpPr>
-          <p:cNvPr id="5" name="TextBox 4"/>
+          <p:cNvPr id="6" name="TextBox 5"/>
           <p:cNvSpPr txBox="1"/>
           <p:nvPr/>
         </p:nvSpPr>
@@ -10731,7 +10534,7 @@
       </p:sp>
       <p:sp>
         <p:nvSpPr>
-          <p:cNvPr id="6" name="TextBox 5"/>
+          <p:cNvPr id="7" name="TextBox 6"/>
           <p:cNvSpPr txBox="1"/>
           <p:nvPr/>
         </p:nvSpPr>
@@ -10767,7 +10570,7 @@
       </p:sp>
       <p:sp>
         <p:nvSpPr>
-          <p:cNvPr id="7" name="TextBox 6"/>
+          <p:cNvPr id="8" name="TextBox 7"/>
           <p:cNvSpPr txBox="1"/>
           <p:nvPr/>
         </p:nvSpPr>
@@ -10803,7 +10606,7 @@
       </p:sp>
       <p:sp>
         <p:nvSpPr>
-          <p:cNvPr id="8" name="TextBox 7"/>
+          <p:cNvPr id="9" name="TextBox 8"/>
           <p:cNvSpPr txBox="1"/>
           <p:nvPr/>
         </p:nvSpPr>
@@ -10839,7 +10642,7 @@
       </p:sp>
       <p:sp>
         <p:nvSpPr>
-          <p:cNvPr id="9" name="TextBox 8"/>
+          <p:cNvPr id="10" name="TextBox 9"/>
           <p:cNvSpPr txBox="1"/>
           <p:nvPr/>
         </p:nvSpPr>
@@ -10875,7 +10678,7 @@
       </p:sp>
       <p:sp>
         <p:nvSpPr>
-          <p:cNvPr id="10" name="TextBox 9"/>
+          <p:cNvPr id="11" name="TextBox 10"/>
           <p:cNvSpPr txBox="1"/>
           <p:nvPr/>
         </p:nvSpPr>
@@ -10911,7 +10714,7 @@
       </p:sp>
       <p:sp>
         <p:nvSpPr>
-          <p:cNvPr id="11" name="Rectangle 10"/>
+          <p:cNvPr id="12" name="Rectangle 11"/>
           <p:cNvSpPr/>
           <p:nvPr/>
         </p:nvSpPr>
@@ -10956,7 +10759,7 @@
       </p:sp>
       <p:sp>
         <p:nvSpPr>
-          <p:cNvPr id="12" name="TextBox 11"/>
+          <p:cNvPr id="13" name="TextBox 12"/>
           <p:cNvSpPr txBox="1"/>
           <p:nvPr/>
         </p:nvSpPr>
@@ -10992,7 +10795,7 @@
       </p:sp>
       <p:sp>
         <p:nvSpPr>
-          <p:cNvPr id="13" name="TextBox 12"/>
+          <p:cNvPr id="14" name="TextBox 13"/>
           <p:cNvSpPr txBox="1"/>
           <p:nvPr/>
         </p:nvSpPr>
@@ -11032,7 +10835,7 @@
       </p:sp>
       <p:sp>
         <p:nvSpPr>
-          <p:cNvPr id="14" name="Rectangle 13"/>
+          <p:cNvPr id="15" name="Rectangle 14"/>
           <p:cNvSpPr/>
           <p:nvPr/>
         </p:nvSpPr>
@@ -11077,7 +10880,7 @@
       </p:sp>
       <p:sp>
         <p:nvSpPr>
-          <p:cNvPr id="15" name="TextBox 14"/>
+          <p:cNvPr id="16" name="TextBox 15"/>
           <p:cNvSpPr txBox="1"/>
           <p:nvPr/>
         </p:nvSpPr>
@@ -11113,7 +10916,7 @@
       </p:sp>
       <p:sp>
         <p:nvSpPr>
-          <p:cNvPr id="16" name="TextBox 15"/>
+          <p:cNvPr id="17" name="TextBox 16"/>
           <p:cNvSpPr txBox="1"/>
           <p:nvPr/>
         </p:nvSpPr>
@@ -11153,7 +10956,7 @@
       </p:sp>
       <p:sp>
         <p:nvSpPr>
-          <p:cNvPr id="17" name="TextBox 16"/>
+          <p:cNvPr id="18" name="TextBox 17"/>
           <p:cNvSpPr txBox="1"/>
           <p:nvPr/>
         </p:nvSpPr>
@@ -11193,7 +10996,7 @@
       </p:sp>
       <p:sp>
         <p:nvSpPr>
-          <p:cNvPr id="18" name="TextBox 17"/>
+          <p:cNvPr id="19" name="TextBox 18"/>
           <p:cNvSpPr txBox="1"/>
           <p:nvPr/>
         </p:nvSpPr>

</xml_diff>